<commit_message>
docs(pitch): rebuild financial model and pitch docs from 2026 cost model
Replace the <GHS 500/month, 2% commission model with one built from
published 2026 prices (Paystack/Hubtel 1.95% collection, GHS 1 payout,
BoG licensing pack, Accra salaries). FX US$1 = GHS 11.60.

- Pricing: 4% all-in (2.5% vendor + 1.5% buyer protection fee); 2%
  loses GHS 4-7 per order after collection fees
- Ask: US$387k pre-seed (stages 1-2, 18 months), ~US$916k seed,
  US$1.30M over 36 months, with low/base/high ranges
- Break-even: ~62,000 orders/month against a staffed GHS 637k/month
  cost base, with fee and ticket-size sensitivity
- GO-TO-MARKET.md section 10 rewritten to match
- Vendor docs and pilot agreement moved to 2.5% and ask about buyer
  acceptance of the 1.5% fee
- Regenerated .docx/.pptx from updated generate_docx.py and
  generate_deck.py
</commit_message>
<xml_diff>
--- a/pitch/Croe_Pitch_Deck.pptx
+++ b/pitch/Croe_Pitch_Deck.pptx
@@ -4,30 +4,27 @@
   <p:sldMasterIdLst>
     <p:sldMasterId id="2147483648" r:id="rId1"/>
   </p:sldMasterIdLst>
-  <p:notesMasterIdLst>
-    <p:notesMasterId r:id="rId20"/>
-  </p:notesMasterIdLst>
   <p:sldIdLst>
-    <p:sldId id="256" r:id="rId2"/>
-    <p:sldId id="257" r:id="rId3"/>
-    <p:sldId id="258" r:id="rId4"/>
-    <p:sldId id="259" r:id="rId5"/>
-    <p:sldId id="260" r:id="rId6"/>
-    <p:sldId id="261" r:id="rId7"/>
-    <p:sldId id="262" r:id="rId8"/>
-    <p:sldId id="263" r:id="rId9"/>
-    <p:sldId id="264" r:id="rId10"/>
-    <p:sldId id="265" r:id="rId11"/>
-    <p:sldId id="266" r:id="rId12"/>
-    <p:sldId id="267" r:id="rId13"/>
-    <p:sldId id="268" r:id="rId14"/>
-    <p:sldId id="269" r:id="rId15"/>
-    <p:sldId id="270" r:id="rId16"/>
-    <p:sldId id="271" r:id="rId17"/>
-    <p:sldId id="272" r:id="rId18"/>
-    <p:sldId id="273" r:id="rId19"/>
+    <p:sldId id="256" r:id="rId7"/>
+    <p:sldId id="257" r:id="rId9"/>
+    <p:sldId id="258" r:id="rId10"/>
+    <p:sldId id="259" r:id="rId11"/>
+    <p:sldId id="260" r:id="rId12"/>
+    <p:sldId id="261" r:id="rId13"/>
+    <p:sldId id="262" r:id="rId14"/>
+    <p:sldId id="263" r:id="rId15"/>
+    <p:sldId id="264" r:id="rId16"/>
+    <p:sldId id="265" r:id="rId17"/>
+    <p:sldId id="266" r:id="rId18"/>
+    <p:sldId id="267" r:id="rId19"/>
+    <p:sldId id="268" r:id="rId20"/>
+    <p:sldId id="269" r:id="rId21"/>
+    <p:sldId id="270" r:id="rId22"/>
+    <p:sldId id="271" r:id="rId23"/>
+    <p:sldId id="272" r:id="rId24"/>
+    <p:sldId id="273" r:id="rId25"/>
   </p:sldIdLst>
-  <p:sldSz cx="12192000" cy="6858000"/>
+  <p:sldSz cx="12191695" cy="6858000" type="screen4x3"/>
   <p:notesSz cx="6858000" cy="9144000"/>
   <p:defaultTextStyle>
     <a:defPPr>
@@ -124,27 +121,11 @@
       </a:defRPr>
     </a:lvl9pPr>
   </p:defaultTextStyle>
-  <p:extLst>
-    <p:ext uri="{EFAFB233-063F-42B5-8137-9DF3F51BA10A}">
-      <p15:sldGuideLst xmlns:p15="http://schemas.microsoft.com/office/powerpoint/2012/main">
-        <p15:guide id="1" orient="horz" pos="2160">
-          <p15:clr>
-            <a:srgbClr val="A4A3A4"/>
-          </p15:clr>
-        </p15:guide>
-        <p15:guide id="2" pos="2880">
-          <p15:clr>
-            <a:srgbClr val="A4A3A4"/>
-          </p15:clr>
-        </p15:guide>
-      </p15:sldGuideLst>
-    </p:ext>
-  </p:extLst>
 </p:presentation>
 </file>
 
 <file path=ppt/notesMasters/notesMaster1.xml><?xml version="1.0" encoding="utf-8"?>
-<p:notesMaster xmlns:a="http://schemas.openxmlformats.org/drawingml/2006/main" xmlns:r="http://schemas.openxmlformats.org/officeDocument/2006/relationships" xmlns:p="http://schemas.openxmlformats.org/presentationml/2006/main">
+<p:notesMaster xmlns:a="http://schemas.openxmlformats.org/drawingml/2006/main" xmlns:p="http://schemas.openxmlformats.org/presentationml/2006/main" xmlns:r="http://schemas.openxmlformats.org/officeDocument/2006/relationships">
   <p:cSld>
     <p:bg>
       <p:bgRef idx="1001">
@@ -165,16 +146,241 @@
           <a:chExt cx="0" cy="0"/>
         </a:xfrm>
       </p:grpSpPr>
+      <p:sp>
+        <p:nvSpPr>
+          <p:cNvPr id="2" name="Header Placeholder 1"/>
+          <p:cNvSpPr>
+            <a:spLocks noGrp="1"/>
+          </p:cNvSpPr>
+          <p:nvPr>
+            <p:ph type="hdr" sz="quarter"/>
+          </p:nvPr>
+        </p:nvSpPr>
+        <p:spPr>
+          <a:xfrm>
+            <a:off x="0" y="0"/>
+            <a:ext cx="2971800" cy="457200"/>
+          </a:xfrm>
+          <a:prstGeom prst="rect">
+            <a:avLst/>
+          </a:prstGeom>
+        </p:spPr>
+        <p:txBody>
+          <a:bodyPr vert="horz" lIns="91440" tIns="45720" rIns="91440" bIns="45720" rtlCol="0"/>
+          <a:lstStyle>
+            <a:lvl1pPr algn="l">
+              <a:defRPr sz="1200"/>
+            </a:lvl1pPr>
+          </a:lstStyle>
+          <a:p>
+            <a:endParaRPr lang="en-US"/>
+          </a:p>
+        </p:txBody>
+      </p:sp>
+      <p:sp>
+        <p:nvSpPr>
+          <p:cNvPr id="3" name="Date Placeholder 2"/>
+          <p:cNvSpPr>
+            <a:spLocks noGrp="1"/>
+          </p:cNvSpPr>
+          <p:nvPr>
+            <p:ph type="dt" idx="1"/>
+          </p:nvPr>
+        </p:nvSpPr>
+        <p:spPr>
+          <a:xfrm>
+            <a:off x="3884613" y="0"/>
+            <a:ext cx="2971800" cy="457200"/>
+          </a:xfrm>
+          <a:prstGeom prst="rect">
+            <a:avLst/>
+          </a:prstGeom>
+        </p:spPr>
+        <p:txBody>
+          <a:bodyPr vert="horz" lIns="91440" tIns="45720" rIns="91440" bIns="45720" rtlCol="0"/>
+          <a:lstStyle>
+            <a:lvl1pPr algn="r">
+              <a:defRPr sz="1200"/>
+            </a:lvl1pPr>
+          </a:lstStyle>
+          <a:p>
+            <a:fld id="{0F89C1C7-3DCD-1040-A9CF-14679D8B5DDD}" type="datetimeFigureOut">
+              <a:rPr lang="en-US" smtClean="0"/>
+              <a:t>10/17/16</a:t>
+            </a:fld>
+            <a:endParaRPr lang="en-US"/>
+          </a:p>
+        </p:txBody>
+      </p:sp>
+      <p:sp>
+        <p:nvSpPr>
+          <p:cNvPr id="4" name="Slide Image Placeholder 3"/>
+          <p:cNvSpPr>
+            <a:spLocks noGrp="1" noRot="1" noChangeAspect="1"/>
+          </p:cNvSpPr>
+          <p:nvPr>
+            <p:ph type="sldImg" idx="2"/>
+          </p:nvPr>
+        </p:nvSpPr>
+        <p:spPr>
+          <a:xfrm>
+            <a:off x="1143000" y="685800"/>
+            <a:ext cx="4572000" cy="3429000"/>
+          </a:xfrm>
+          <a:prstGeom prst="rect">
+            <a:avLst/>
+          </a:prstGeom>
+          <a:noFill/>
+          <a:ln w="12700">
+            <a:solidFill>
+              <a:prstClr val="black"/>
+            </a:solidFill>
+          </a:ln>
+        </p:spPr>
+        <p:txBody>
+          <a:bodyPr vert="horz" lIns="91440" tIns="45720" rIns="91440" bIns="45720" rtlCol="0" anchor="ctr"/>
+          <a:lstStyle/>
+          <a:p>
+            <a:endParaRPr lang="en-US"/>
+          </a:p>
+        </p:txBody>
+      </p:sp>
+      <p:sp>
+        <p:nvSpPr>
+          <p:cNvPr id="5" name="Notes Placeholder 4"/>
+          <p:cNvSpPr>
+            <a:spLocks noGrp="1"/>
+          </p:cNvSpPr>
+          <p:nvPr>
+            <p:ph type="body" sz="quarter" idx="3"/>
+          </p:nvPr>
+        </p:nvSpPr>
+        <p:spPr>
+          <a:xfrm>
+            <a:off x="685800" y="4343400"/>
+            <a:ext cx="5486400" cy="4114800"/>
+          </a:xfrm>
+          <a:prstGeom prst="rect">
+            <a:avLst/>
+          </a:prstGeom>
+        </p:spPr>
+        <p:txBody>
+          <a:bodyPr vert="horz" lIns="91440" tIns="45720" rIns="91440" bIns="45720" rtlCol="0"/>
+          <a:lstStyle/>
+          <a:p>
+            <a:pPr lvl="0"/>
+            <a:r>
+              <a:rPr lang="en-US" smtClean="0"/>
+              <a:t>Click to edit Master text styles</a:t>
+            </a:r>
+          </a:p>
+          <a:p>
+            <a:pPr lvl="1"/>
+            <a:r>
+              <a:rPr lang="en-US" smtClean="0"/>
+              <a:t>Second level</a:t>
+            </a:r>
+          </a:p>
+          <a:p>
+            <a:pPr lvl="2"/>
+            <a:r>
+              <a:rPr lang="en-US" smtClean="0"/>
+              <a:t>Third level</a:t>
+            </a:r>
+          </a:p>
+          <a:p>
+            <a:pPr lvl="3"/>
+            <a:r>
+              <a:rPr lang="en-US" smtClean="0"/>
+              <a:t>Fourth level</a:t>
+            </a:r>
+          </a:p>
+          <a:p>
+            <a:pPr lvl="4"/>
+            <a:r>
+              <a:rPr lang="en-US" smtClean="0"/>
+              <a:t>Fifth level</a:t>
+            </a:r>
+            <a:endParaRPr lang="en-US"/>
+          </a:p>
+        </p:txBody>
+      </p:sp>
+      <p:sp>
+        <p:nvSpPr>
+          <p:cNvPr id="6" name="Footer Placeholder 5"/>
+          <p:cNvSpPr>
+            <a:spLocks noGrp="1"/>
+          </p:cNvSpPr>
+          <p:nvPr>
+            <p:ph type="ftr" sz="quarter" idx="4"/>
+          </p:nvPr>
+        </p:nvSpPr>
+        <p:spPr>
+          <a:xfrm>
+            <a:off x="0" y="8685213"/>
+            <a:ext cx="2971800" cy="457200"/>
+          </a:xfrm>
+          <a:prstGeom prst="rect">
+            <a:avLst/>
+          </a:prstGeom>
+        </p:spPr>
+        <p:txBody>
+          <a:bodyPr vert="horz" lIns="91440" tIns="45720" rIns="91440" bIns="45720" rtlCol="0" anchor="b"/>
+          <a:lstStyle>
+            <a:lvl1pPr algn="l">
+              <a:defRPr sz="1200"/>
+            </a:lvl1pPr>
+          </a:lstStyle>
+          <a:p>
+            <a:endParaRPr lang="en-US"/>
+          </a:p>
+        </p:txBody>
+      </p:sp>
+      <p:sp>
+        <p:nvSpPr>
+          <p:cNvPr id="7" name="Slide Number Placeholder 6"/>
+          <p:cNvSpPr>
+            <a:spLocks noGrp="1"/>
+          </p:cNvSpPr>
+          <p:nvPr>
+            <p:ph type="sldNum" sz="quarter" idx="5"/>
+          </p:nvPr>
+        </p:nvSpPr>
+        <p:spPr>
+          <a:xfrm>
+            <a:off x="3884613" y="8685213"/>
+            <a:ext cx="2971800" cy="457200"/>
+          </a:xfrm>
+          <a:prstGeom prst="rect">
+            <a:avLst/>
+          </a:prstGeom>
+        </p:spPr>
+        <p:txBody>
+          <a:bodyPr vert="horz" lIns="91440" tIns="45720" rIns="91440" bIns="45720" rtlCol="0" anchor="b"/>
+          <a:lstStyle>
+            <a:lvl1pPr algn="r">
+              <a:defRPr sz="1200"/>
+            </a:lvl1pPr>
+          </a:lstStyle>
+          <a:p>
+            <a:fld id="{BB5E49A5-4136-284D-997B-48E1D791AD67}" type="slidenum">
+              <a:rPr lang="en-US" smtClean="0"/>
+              <a:t>‹#›</a:t>
+            </a:fld>
+            <a:endParaRPr lang="en-US"/>
+          </a:p>
+        </p:txBody>
+      </p:sp>
     </p:spTree>
     <p:extLst>
       <p:ext uri="{BB962C8B-B14F-4D97-AF65-F5344CB8AC3E}">
-        <p14:creationId xmlns:p14="http://schemas.microsoft.com/office/powerpoint/2010/main" val="1293903974"/>
+        <p14:creationId xmlns:p14="http://schemas.microsoft.com/office/powerpoint/2010/main" val="2623252185"/>
       </p:ext>
     </p:extLst>
   </p:cSld>
   <p:clrMap bg1="lt1" tx1="dk1" bg2="lt2" tx2="dk2" accent1="accent1" accent2="accent2" accent3="accent3" accent4="accent4" accent5="accent5" accent6="accent6" hlink="hlink" folHlink="folHlink"/>
   <p:notesStyle>
-    <a:lvl1pPr marL="0" algn="l" defTabSz="914400" rtl="0" eaLnBrk="1" latinLnBrk="0" hangingPunct="1">
+    <a:lvl1pPr marL="0" algn="l" defTabSz="457200" rtl="0" eaLnBrk="1" latinLnBrk="0" hangingPunct="1">
       <a:defRPr sz="1200" kern="1200">
         <a:solidFill>
           <a:schemeClr val="tx1"/>
@@ -184,7 +390,7 @@
         <a:cs typeface="+mn-cs"/>
       </a:defRPr>
     </a:lvl1pPr>
-    <a:lvl2pPr marL="457200" algn="l" defTabSz="914400" rtl="0" eaLnBrk="1" latinLnBrk="0" hangingPunct="1">
+    <a:lvl2pPr marL="457200" algn="l" defTabSz="457200" rtl="0" eaLnBrk="1" latinLnBrk="0" hangingPunct="1">
       <a:defRPr sz="1200" kern="1200">
         <a:solidFill>
           <a:schemeClr val="tx1"/>
@@ -194,7 +400,7 @@
         <a:cs typeface="+mn-cs"/>
       </a:defRPr>
     </a:lvl2pPr>
-    <a:lvl3pPr marL="914400" algn="l" defTabSz="914400" rtl="0" eaLnBrk="1" latinLnBrk="0" hangingPunct="1">
+    <a:lvl3pPr marL="914400" algn="l" defTabSz="457200" rtl="0" eaLnBrk="1" latinLnBrk="0" hangingPunct="1">
       <a:defRPr sz="1200" kern="1200">
         <a:solidFill>
           <a:schemeClr val="tx1"/>
@@ -204,7 +410,7 @@
         <a:cs typeface="+mn-cs"/>
       </a:defRPr>
     </a:lvl3pPr>
-    <a:lvl4pPr marL="1371600" algn="l" defTabSz="914400" rtl="0" eaLnBrk="1" latinLnBrk="0" hangingPunct="1">
+    <a:lvl4pPr marL="1371600" algn="l" defTabSz="457200" rtl="0" eaLnBrk="1" latinLnBrk="0" hangingPunct="1">
       <a:defRPr sz="1200" kern="1200">
         <a:solidFill>
           <a:schemeClr val="tx1"/>
@@ -214,7 +420,7 @@
         <a:cs typeface="+mn-cs"/>
       </a:defRPr>
     </a:lvl4pPr>
-    <a:lvl5pPr marL="1828800" algn="l" defTabSz="914400" rtl="0" eaLnBrk="1" latinLnBrk="0" hangingPunct="1">
+    <a:lvl5pPr marL="1828800" algn="l" defTabSz="457200" rtl="0" eaLnBrk="1" latinLnBrk="0" hangingPunct="1">
       <a:defRPr sz="1200" kern="1200">
         <a:solidFill>
           <a:schemeClr val="tx1"/>
@@ -224,7 +430,7 @@
         <a:cs typeface="+mn-cs"/>
       </a:defRPr>
     </a:lvl5pPr>
-    <a:lvl6pPr marL="2286000" algn="l" defTabSz="914400" rtl="0" eaLnBrk="1" latinLnBrk="0" hangingPunct="1">
+    <a:lvl6pPr marL="2286000" algn="l" defTabSz="457200" rtl="0" eaLnBrk="1" latinLnBrk="0" hangingPunct="1">
       <a:defRPr sz="1200" kern="1200">
         <a:solidFill>
           <a:schemeClr val="tx1"/>
@@ -234,7 +440,7 @@
         <a:cs typeface="+mn-cs"/>
       </a:defRPr>
     </a:lvl6pPr>
-    <a:lvl7pPr marL="2743200" algn="l" defTabSz="914400" rtl="0" eaLnBrk="1" latinLnBrk="0" hangingPunct="1">
+    <a:lvl7pPr marL="2743200" algn="l" defTabSz="457200" rtl="0" eaLnBrk="1" latinLnBrk="0" hangingPunct="1">
       <a:defRPr sz="1200" kern="1200">
         <a:solidFill>
           <a:schemeClr val="tx1"/>
@@ -244,7 +450,7 @@
         <a:cs typeface="+mn-cs"/>
       </a:defRPr>
     </a:lvl7pPr>
-    <a:lvl8pPr marL="3200400" algn="l" defTabSz="914400" rtl="0" eaLnBrk="1" latinLnBrk="0" hangingPunct="1">
+    <a:lvl8pPr marL="3200400" algn="l" defTabSz="457200" rtl="0" eaLnBrk="1" latinLnBrk="0" hangingPunct="1">
       <a:defRPr sz="1200" kern="1200">
         <a:solidFill>
           <a:schemeClr val="tx1"/>
@@ -254,7 +460,7 @@
         <a:cs typeface="+mn-cs"/>
       </a:defRPr>
     </a:lvl8pPr>
-    <a:lvl9pPr marL="3657600" algn="l" defTabSz="914400" rtl="0" eaLnBrk="1" latinLnBrk="0" hangingPunct="1">
+    <a:lvl9pPr marL="3657600" algn="l" defTabSz="457200" rtl="0" eaLnBrk="1" latinLnBrk="0" hangingPunct="1">
       <a:defRPr sz="1200" kern="1200">
         <a:solidFill>
           <a:schemeClr val="tx1"/>
@@ -269,7 +475,7 @@
 </file>
 
 <file path=ppt/notesSlides/notesSlide1.xml><?xml version="1.0" encoding="utf-8"?>
-<p:notes xmlns:a="http://schemas.openxmlformats.org/drawingml/2006/main" xmlns:r="http://schemas.openxmlformats.org/officeDocument/2006/relationships" xmlns:p="http://schemas.openxmlformats.org/presentationml/2006/main">
+<p:notes xmlns:a="http://schemas.openxmlformats.org/drawingml/2006/main" xmlns:p="http://schemas.openxmlformats.org/presentationml/2006/main" xmlns:r="http://schemas.openxmlformats.org/officeDocument/2006/relationships">
   <p:cSld>
     <p:spTree>
       <p:nvGrpSpPr>
@@ -289,7 +495,7 @@
         <p:nvSpPr>
           <p:cNvPr id="2" name="Slide Image Placeholder 1"/>
           <p:cNvSpPr>
-            <a:spLocks noGrp="1" noRot="1" noChangeAspect="1"/>
+            <a:spLocks noGrp="1"/>
           </p:cNvSpPr>
           <p:nvPr>
             <p:ph type="sldImg" idx="2"/>
@@ -304,7 +510,7 @@
             <a:spLocks noGrp="1"/>
           </p:cNvSpPr>
           <p:nvPr>
-            <p:ph type="body" sz="quarter" idx="3"/>
+            <p:ph type="body" idx="3" sz="quarter"/>
           </p:nvPr>
         </p:nvSpPr>
         <p:spPr/>
@@ -325,7 +531,7 @@
             <a:spLocks noGrp="1"/>
           </p:cNvSpPr>
           <p:nvPr>
-            <p:ph type="sldNum" sz="quarter" idx="5"/>
+            <p:ph type="sldNum" idx="5" sz="quarter"/>
           </p:nvPr>
         </p:nvSpPr>
         <p:spPr/>
@@ -339,7 +545,7 @@
 </file>
 
 <file path=ppt/notesSlides/notesSlide10.xml><?xml version="1.0" encoding="utf-8"?>
-<p:notes xmlns:a="http://schemas.openxmlformats.org/drawingml/2006/main" xmlns:r="http://schemas.openxmlformats.org/officeDocument/2006/relationships" xmlns:p="http://schemas.openxmlformats.org/presentationml/2006/main">
+<p:notes xmlns:a="http://schemas.openxmlformats.org/drawingml/2006/main" xmlns:p="http://schemas.openxmlformats.org/presentationml/2006/main" xmlns:r="http://schemas.openxmlformats.org/officeDocument/2006/relationships">
   <p:cSld>
     <p:spTree>
       <p:nvGrpSpPr>
@@ -359,7 +565,7 @@
         <p:nvSpPr>
           <p:cNvPr id="2" name="Slide Image Placeholder 1"/>
           <p:cNvSpPr>
-            <a:spLocks noGrp="1" noRot="1" noChangeAspect="1"/>
+            <a:spLocks noGrp="1"/>
           </p:cNvSpPr>
           <p:nvPr>
             <p:ph type="sldImg" idx="2"/>
@@ -374,7 +580,7 @@
             <a:spLocks noGrp="1"/>
           </p:cNvSpPr>
           <p:nvPr>
-            <p:ph type="body" sz="quarter" idx="3"/>
+            <p:ph type="body" idx="3" sz="quarter"/>
           </p:nvPr>
         </p:nvSpPr>
         <p:spPr/>
@@ -395,7 +601,7 @@
             <a:spLocks noGrp="1"/>
           </p:cNvSpPr>
           <p:nvPr>
-            <p:ph type="sldNum" sz="quarter" idx="5"/>
+            <p:ph type="sldNum" idx="5" sz="quarter"/>
           </p:nvPr>
         </p:nvSpPr>
         <p:spPr/>
@@ -409,7 +615,7 @@
 </file>
 
 <file path=ppt/notesSlides/notesSlide11.xml><?xml version="1.0" encoding="utf-8"?>
-<p:notes xmlns:a="http://schemas.openxmlformats.org/drawingml/2006/main" xmlns:r="http://schemas.openxmlformats.org/officeDocument/2006/relationships" xmlns:p="http://schemas.openxmlformats.org/presentationml/2006/main">
+<p:notes xmlns:a="http://schemas.openxmlformats.org/drawingml/2006/main" xmlns:p="http://schemas.openxmlformats.org/presentationml/2006/main" xmlns:r="http://schemas.openxmlformats.org/officeDocument/2006/relationships">
   <p:cSld>
     <p:spTree>
       <p:nvGrpSpPr>
@@ -429,7 +635,7 @@
         <p:nvSpPr>
           <p:cNvPr id="2" name="Slide Image Placeholder 1"/>
           <p:cNvSpPr>
-            <a:spLocks noGrp="1" noRot="1" noChangeAspect="1"/>
+            <a:spLocks noGrp="1"/>
           </p:cNvSpPr>
           <p:nvPr>
             <p:ph type="sldImg" idx="2"/>
@@ -444,7 +650,7 @@
             <a:spLocks noGrp="1"/>
           </p:cNvSpPr>
           <p:nvPr>
-            <p:ph type="body" sz="quarter" idx="3"/>
+            <p:ph type="body" idx="3" sz="quarter"/>
           </p:nvPr>
         </p:nvSpPr>
         <p:spPr/>
@@ -465,7 +671,7 @@
             <a:spLocks noGrp="1"/>
           </p:cNvSpPr>
           <p:nvPr>
-            <p:ph type="sldNum" sz="quarter" idx="5"/>
+            <p:ph type="sldNum" idx="5" sz="quarter"/>
           </p:nvPr>
         </p:nvSpPr>
         <p:spPr/>
@@ -479,7 +685,7 @@
 </file>
 
 <file path=ppt/notesSlides/notesSlide12.xml><?xml version="1.0" encoding="utf-8"?>
-<p:notes xmlns:a="http://schemas.openxmlformats.org/drawingml/2006/main" xmlns:r="http://schemas.openxmlformats.org/officeDocument/2006/relationships" xmlns:p="http://schemas.openxmlformats.org/presentationml/2006/main">
+<p:notes xmlns:a="http://schemas.openxmlformats.org/drawingml/2006/main" xmlns:p="http://schemas.openxmlformats.org/presentationml/2006/main" xmlns:r="http://schemas.openxmlformats.org/officeDocument/2006/relationships">
   <p:cSld>
     <p:spTree>
       <p:nvGrpSpPr>
@@ -499,7 +705,7 @@
         <p:nvSpPr>
           <p:cNvPr id="2" name="Slide Image Placeholder 1"/>
           <p:cNvSpPr>
-            <a:spLocks noGrp="1" noRot="1" noChangeAspect="1"/>
+            <a:spLocks noGrp="1"/>
           </p:cNvSpPr>
           <p:nvPr>
             <p:ph type="sldImg" idx="2"/>
@@ -514,7 +720,7 @@
             <a:spLocks noGrp="1"/>
           </p:cNvSpPr>
           <p:nvPr>
-            <p:ph type="body" sz="quarter" idx="3"/>
+            <p:ph type="body" idx="3" sz="quarter"/>
           </p:nvPr>
         </p:nvSpPr>
         <p:spPr/>
@@ -523,7 +729,7 @@
           <a:lstStyle/>
           <a:p>
             <a:r>
-              <a:t>Tie the number to the milestone: Track A proves unit economics and conversion for $2.5k. Track B provides institutional security and legal de-risking for institutional funds.</a:t>
+              <a:t>Tie the number to the milestone. Pre-seed US$387k (range US$189k-713k) covers stages 1-2 over 18 months, with 15% contingency and working capital; FX US$1 = GHS 11.60. Most of stage 2 is people: the BoG names five management roles in its licensing pack. A seed round of ~US$916k around month 15 funds scale to ~30,000 orders/month; US$1.30M total over 36 months. Line items and sources: FINANCIAL-MODEL.md.</a:t>
             </a:r>
           </a:p>
         </p:txBody>
@@ -535,7 +741,7 @@
             <a:spLocks noGrp="1"/>
           </p:cNvSpPr>
           <p:nvPr>
-            <p:ph type="sldNum" sz="quarter" idx="5"/>
+            <p:ph type="sldNum" idx="5" sz="quarter"/>
           </p:nvPr>
         </p:nvSpPr>
         <p:spPr/>
@@ -549,7 +755,7 @@
 </file>
 
 <file path=ppt/notesSlides/notesSlide13.xml><?xml version="1.0" encoding="utf-8"?>
-<p:notes xmlns:a="http://schemas.openxmlformats.org/drawingml/2006/main" xmlns:r="http://schemas.openxmlformats.org/officeDocument/2006/relationships" xmlns:p="http://schemas.openxmlformats.org/presentationml/2006/main">
+<p:notes xmlns:a="http://schemas.openxmlformats.org/drawingml/2006/main" xmlns:p="http://schemas.openxmlformats.org/presentationml/2006/main" xmlns:r="http://schemas.openxmlformats.org/officeDocument/2006/relationships">
   <p:cSld>
     <p:spTree>
       <p:nvGrpSpPr>
@@ -569,7 +775,7 @@
         <p:nvSpPr>
           <p:cNvPr id="2" name="Slide Image Placeholder 1"/>
           <p:cNvSpPr>
-            <a:spLocks noGrp="1" noRot="1" noChangeAspect="1"/>
+            <a:spLocks noGrp="1"/>
           </p:cNvSpPr>
           <p:nvPr>
             <p:ph type="sldImg" idx="2"/>
@@ -584,7 +790,7 @@
             <a:spLocks noGrp="1"/>
           </p:cNvSpPr>
           <p:nvPr>
-            <p:ph type="body" sz="quarter" idx="3"/>
+            <p:ph type="body" idx="3" sz="quarter"/>
           </p:nvPr>
         </p:nvSpPr>
         <p:spPr/>
@@ -605,7 +811,7 @@
             <a:spLocks noGrp="1"/>
           </p:cNvSpPr>
           <p:nvPr>
-            <p:ph type="sldNum" sz="quarter" idx="5"/>
+            <p:ph type="sldNum" idx="5" sz="quarter"/>
           </p:nvPr>
         </p:nvSpPr>
         <p:spPr/>
@@ -619,7 +825,7 @@
 </file>
 
 <file path=ppt/notesSlides/notesSlide14.xml><?xml version="1.0" encoding="utf-8"?>
-<p:notes xmlns:a="http://schemas.openxmlformats.org/drawingml/2006/main" xmlns:r="http://schemas.openxmlformats.org/officeDocument/2006/relationships" xmlns:p="http://schemas.openxmlformats.org/presentationml/2006/main">
+<p:notes xmlns:a="http://schemas.openxmlformats.org/drawingml/2006/main" xmlns:p="http://schemas.openxmlformats.org/presentationml/2006/main" xmlns:r="http://schemas.openxmlformats.org/officeDocument/2006/relationships">
   <p:cSld>
     <p:spTree>
       <p:nvGrpSpPr>
@@ -639,7 +845,7 @@
         <p:nvSpPr>
           <p:cNvPr id="2" name="Slide Image Placeholder 1"/>
           <p:cNvSpPr>
-            <a:spLocks noGrp="1" noRot="1" noChangeAspect="1"/>
+            <a:spLocks noGrp="1"/>
           </p:cNvSpPr>
           <p:nvPr>
             <p:ph type="sldImg" idx="2"/>
@@ -654,7 +860,7 @@
             <a:spLocks noGrp="1"/>
           </p:cNvSpPr>
           <p:nvPr>
-            <p:ph type="body" sz="quarter" idx="3"/>
+            <p:ph type="body" idx="3" sz="quarter"/>
           </p:nvPr>
         </p:nvSpPr>
         <p:spPr/>
@@ -675,7 +881,7 @@
             <a:spLocks noGrp="1"/>
           </p:cNvSpPr>
           <p:nvPr>
-            <p:ph type="sldNum" sz="quarter" idx="5"/>
+            <p:ph type="sldNum" idx="5" sz="quarter"/>
           </p:nvPr>
         </p:nvSpPr>
         <p:spPr/>
@@ -689,7 +895,7 @@
 </file>
 
 <file path=ppt/notesSlides/notesSlide15.xml><?xml version="1.0" encoding="utf-8"?>
-<p:notes xmlns:a="http://schemas.openxmlformats.org/drawingml/2006/main" xmlns:r="http://schemas.openxmlformats.org/officeDocument/2006/relationships" xmlns:p="http://schemas.openxmlformats.org/presentationml/2006/main">
+<p:notes xmlns:a="http://schemas.openxmlformats.org/drawingml/2006/main" xmlns:p="http://schemas.openxmlformats.org/presentationml/2006/main" xmlns:r="http://schemas.openxmlformats.org/officeDocument/2006/relationships">
   <p:cSld>
     <p:spTree>
       <p:nvGrpSpPr>
@@ -709,7 +915,7 @@
         <p:nvSpPr>
           <p:cNvPr id="2" name="Slide Image Placeholder 1"/>
           <p:cNvSpPr>
-            <a:spLocks noGrp="1" noRot="1" noChangeAspect="1"/>
+            <a:spLocks noGrp="1"/>
           </p:cNvSpPr>
           <p:nvPr>
             <p:ph type="sldImg" idx="2"/>
@@ -724,7 +930,7 @@
             <a:spLocks noGrp="1"/>
           </p:cNvSpPr>
           <p:nvPr>
-            <p:ph type="body" sz="quarter" idx="3"/>
+            <p:ph type="body" idx="3" sz="quarter"/>
           </p:nvPr>
         </p:nvSpPr>
         <p:spPr/>
@@ -745,7 +951,7 @@
             <a:spLocks noGrp="1"/>
           </p:cNvSpPr>
           <p:nvPr>
-            <p:ph type="sldNum" sz="quarter" idx="5"/>
+            <p:ph type="sldNum" idx="5" sz="quarter"/>
           </p:nvPr>
         </p:nvSpPr>
         <p:spPr/>
@@ -759,7 +965,7 @@
 </file>
 
 <file path=ppt/notesSlides/notesSlide16.xml><?xml version="1.0" encoding="utf-8"?>
-<p:notes xmlns:a="http://schemas.openxmlformats.org/drawingml/2006/main" xmlns:r="http://schemas.openxmlformats.org/officeDocument/2006/relationships" xmlns:p="http://schemas.openxmlformats.org/presentationml/2006/main">
+<p:notes xmlns:a="http://schemas.openxmlformats.org/drawingml/2006/main" xmlns:p="http://schemas.openxmlformats.org/presentationml/2006/main" xmlns:r="http://schemas.openxmlformats.org/officeDocument/2006/relationships">
   <p:cSld>
     <p:spTree>
       <p:nvGrpSpPr>
@@ -779,7 +985,7 @@
         <p:nvSpPr>
           <p:cNvPr id="2" name="Slide Image Placeholder 1"/>
           <p:cNvSpPr>
-            <a:spLocks noGrp="1" noRot="1" noChangeAspect="1"/>
+            <a:spLocks noGrp="1"/>
           </p:cNvSpPr>
           <p:nvPr>
             <p:ph type="sldImg" idx="2"/>
@@ -794,7 +1000,7 @@
             <a:spLocks noGrp="1"/>
           </p:cNvSpPr>
           <p:nvPr>
-            <p:ph type="body" sz="quarter" idx="3"/>
+            <p:ph type="body" idx="3" sz="quarter"/>
           </p:nvPr>
         </p:nvSpPr>
         <p:spPr/>
@@ -815,7 +1021,7 @@
             <a:spLocks noGrp="1"/>
           </p:cNvSpPr>
           <p:nvPr>
-            <p:ph type="sldNum" sz="quarter" idx="5"/>
+            <p:ph type="sldNum" idx="5" sz="quarter"/>
           </p:nvPr>
         </p:nvSpPr>
         <p:spPr/>
@@ -829,7 +1035,7 @@
 </file>
 
 <file path=ppt/notesSlides/notesSlide17.xml><?xml version="1.0" encoding="utf-8"?>
-<p:notes xmlns:a="http://schemas.openxmlformats.org/drawingml/2006/main" xmlns:r="http://schemas.openxmlformats.org/officeDocument/2006/relationships" xmlns:p="http://schemas.openxmlformats.org/presentationml/2006/main">
+<p:notes xmlns:a="http://schemas.openxmlformats.org/drawingml/2006/main" xmlns:p="http://schemas.openxmlformats.org/presentationml/2006/main" xmlns:r="http://schemas.openxmlformats.org/officeDocument/2006/relationships">
   <p:cSld>
     <p:spTree>
       <p:nvGrpSpPr>
@@ -849,7 +1055,7 @@
         <p:nvSpPr>
           <p:cNvPr id="2" name="Slide Image Placeholder 1"/>
           <p:cNvSpPr>
-            <a:spLocks noGrp="1" noRot="1" noChangeAspect="1"/>
+            <a:spLocks noGrp="1"/>
           </p:cNvSpPr>
           <p:nvPr>
             <p:ph type="sldImg" idx="2"/>
@@ -864,7 +1070,7 @@
             <a:spLocks noGrp="1"/>
           </p:cNvSpPr>
           <p:nvPr>
-            <p:ph type="body" sz="quarter" idx="3"/>
+            <p:ph type="body" idx="3" sz="quarter"/>
           </p:nvPr>
         </p:nvSpPr>
         <p:spPr/>
@@ -885,7 +1091,7 @@
             <a:spLocks noGrp="1"/>
           </p:cNvSpPr>
           <p:nvPr>
-            <p:ph type="sldNum" sz="quarter" idx="5"/>
+            <p:ph type="sldNum" idx="5" sz="quarter"/>
           </p:nvPr>
         </p:nvSpPr>
         <p:spPr/>
@@ -899,7 +1105,7 @@
 </file>
 
 <file path=ppt/notesSlides/notesSlide18.xml><?xml version="1.0" encoding="utf-8"?>
-<p:notes xmlns:a="http://schemas.openxmlformats.org/drawingml/2006/main" xmlns:r="http://schemas.openxmlformats.org/officeDocument/2006/relationships" xmlns:p="http://schemas.openxmlformats.org/presentationml/2006/main">
+<p:notes xmlns:a="http://schemas.openxmlformats.org/drawingml/2006/main" xmlns:p="http://schemas.openxmlformats.org/presentationml/2006/main" xmlns:r="http://schemas.openxmlformats.org/officeDocument/2006/relationships">
   <p:cSld>
     <p:spTree>
       <p:nvGrpSpPr>
@@ -919,7 +1125,7 @@
         <p:nvSpPr>
           <p:cNvPr id="2" name="Slide Image Placeholder 1"/>
           <p:cNvSpPr>
-            <a:spLocks noGrp="1" noRot="1" noChangeAspect="1"/>
+            <a:spLocks noGrp="1"/>
           </p:cNvSpPr>
           <p:nvPr>
             <p:ph type="sldImg" idx="2"/>
@@ -934,7 +1140,7 @@
             <a:spLocks noGrp="1"/>
           </p:cNvSpPr>
           <p:nvPr>
-            <p:ph type="body" sz="quarter" idx="3"/>
+            <p:ph type="body" idx="3" sz="quarter"/>
           </p:nvPr>
         </p:nvSpPr>
         <p:spPr/>
@@ -955,7 +1161,7 @@
             <a:spLocks noGrp="1"/>
           </p:cNvSpPr>
           <p:nvPr>
-            <p:ph type="sldNum" sz="quarter" idx="5"/>
+            <p:ph type="sldNum" idx="5" sz="quarter"/>
           </p:nvPr>
         </p:nvSpPr>
         <p:spPr/>
@@ -969,7 +1175,7 @@
 </file>
 
 <file path=ppt/notesSlides/notesSlide2.xml><?xml version="1.0" encoding="utf-8"?>
-<p:notes xmlns:a="http://schemas.openxmlformats.org/drawingml/2006/main" xmlns:r="http://schemas.openxmlformats.org/officeDocument/2006/relationships" xmlns:p="http://schemas.openxmlformats.org/presentationml/2006/main">
+<p:notes xmlns:a="http://schemas.openxmlformats.org/drawingml/2006/main" xmlns:p="http://schemas.openxmlformats.org/presentationml/2006/main" xmlns:r="http://schemas.openxmlformats.org/officeDocument/2006/relationships">
   <p:cSld>
     <p:spTree>
       <p:nvGrpSpPr>
@@ -989,7 +1195,7 @@
         <p:nvSpPr>
           <p:cNvPr id="2" name="Slide Image Placeholder 1"/>
           <p:cNvSpPr>
-            <a:spLocks noGrp="1" noRot="1" noChangeAspect="1"/>
+            <a:spLocks noGrp="1"/>
           </p:cNvSpPr>
           <p:nvPr>
             <p:ph type="sldImg" idx="2"/>
@@ -1004,7 +1210,7 @@
             <a:spLocks noGrp="1"/>
           </p:cNvSpPr>
           <p:nvPr>
-            <p:ph type="body" sz="quarter" idx="3"/>
+            <p:ph type="body" idx="3" sz="quarter"/>
           </p:nvPr>
         </p:nvSpPr>
         <p:spPr/>
@@ -1025,7 +1231,7 @@
             <a:spLocks noGrp="1"/>
           </p:cNvSpPr>
           <p:nvPr>
-            <p:ph type="sldNum" sz="quarter" idx="5"/>
+            <p:ph type="sldNum" idx="5" sz="quarter"/>
           </p:nvPr>
         </p:nvSpPr>
         <p:spPr/>
@@ -1039,7 +1245,7 @@
 </file>
 
 <file path=ppt/notesSlides/notesSlide3.xml><?xml version="1.0" encoding="utf-8"?>
-<p:notes xmlns:a="http://schemas.openxmlformats.org/drawingml/2006/main" xmlns:r="http://schemas.openxmlformats.org/officeDocument/2006/relationships" xmlns:p="http://schemas.openxmlformats.org/presentationml/2006/main">
+<p:notes xmlns:a="http://schemas.openxmlformats.org/drawingml/2006/main" xmlns:p="http://schemas.openxmlformats.org/presentationml/2006/main" xmlns:r="http://schemas.openxmlformats.org/officeDocument/2006/relationships">
   <p:cSld>
     <p:spTree>
       <p:nvGrpSpPr>
@@ -1059,7 +1265,7 @@
         <p:nvSpPr>
           <p:cNvPr id="2" name="Slide Image Placeholder 1"/>
           <p:cNvSpPr>
-            <a:spLocks noGrp="1" noRot="1" noChangeAspect="1"/>
+            <a:spLocks noGrp="1"/>
           </p:cNvSpPr>
           <p:nvPr>
             <p:ph type="sldImg" idx="2"/>
@@ -1074,7 +1280,7 @@
             <a:spLocks noGrp="1"/>
           </p:cNvSpPr>
           <p:nvPr>
-            <p:ph type="body" sz="quarter" idx="3"/>
+            <p:ph type="body" idx="3" sz="quarter"/>
           </p:nvPr>
         </p:nvSpPr>
         <p:spPr/>
@@ -1095,7 +1301,7 @@
             <a:spLocks noGrp="1"/>
           </p:cNvSpPr>
           <p:nvPr>
-            <p:ph type="sldNum" sz="quarter" idx="5"/>
+            <p:ph type="sldNum" idx="5" sz="quarter"/>
           </p:nvPr>
         </p:nvSpPr>
         <p:spPr/>
@@ -1109,7 +1315,7 @@
 </file>
 
 <file path=ppt/notesSlides/notesSlide4.xml><?xml version="1.0" encoding="utf-8"?>
-<p:notes xmlns:a="http://schemas.openxmlformats.org/drawingml/2006/main" xmlns:r="http://schemas.openxmlformats.org/officeDocument/2006/relationships" xmlns:p="http://schemas.openxmlformats.org/presentationml/2006/main">
+<p:notes xmlns:a="http://schemas.openxmlformats.org/drawingml/2006/main" xmlns:p="http://schemas.openxmlformats.org/presentationml/2006/main" xmlns:r="http://schemas.openxmlformats.org/officeDocument/2006/relationships">
   <p:cSld>
     <p:spTree>
       <p:nvGrpSpPr>
@@ -1129,7 +1335,7 @@
         <p:nvSpPr>
           <p:cNvPr id="2" name="Slide Image Placeholder 1"/>
           <p:cNvSpPr>
-            <a:spLocks noGrp="1" noRot="1" noChangeAspect="1"/>
+            <a:spLocks noGrp="1"/>
           </p:cNvSpPr>
           <p:nvPr>
             <p:ph type="sldImg" idx="2"/>
@@ -1144,7 +1350,7 @@
             <a:spLocks noGrp="1"/>
           </p:cNvSpPr>
           <p:nvPr>
-            <p:ph type="body" sz="quarter" idx="3"/>
+            <p:ph type="body" idx="3" sz="quarter"/>
           </p:nvPr>
         </p:nvSpPr>
         <p:spPr/>
@@ -1165,7 +1371,7 @@
             <a:spLocks noGrp="1"/>
           </p:cNvSpPr>
           <p:nvPr>
-            <p:ph type="sldNum" sz="quarter" idx="5"/>
+            <p:ph type="sldNum" idx="5" sz="quarter"/>
           </p:nvPr>
         </p:nvSpPr>
         <p:spPr/>
@@ -1179,7 +1385,7 @@
 </file>
 
 <file path=ppt/notesSlides/notesSlide5.xml><?xml version="1.0" encoding="utf-8"?>
-<p:notes xmlns:a="http://schemas.openxmlformats.org/drawingml/2006/main" xmlns:r="http://schemas.openxmlformats.org/officeDocument/2006/relationships" xmlns:p="http://schemas.openxmlformats.org/presentationml/2006/main">
+<p:notes xmlns:a="http://schemas.openxmlformats.org/drawingml/2006/main" xmlns:p="http://schemas.openxmlformats.org/presentationml/2006/main" xmlns:r="http://schemas.openxmlformats.org/officeDocument/2006/relationships">
   <p:cSld>
     <p:spTree>
       <p:nvGrpSpPr>
@@ -1199,7 +1405,7 @@
         <p:nvSpPr>
           <p:cNvPr id="2" name="Slide Image Placeholder 1"/>
           <p:cNvSpPr>
-            <a:spLocks noGrp="1" noRot="1" noChangeAspect="1"/>
+            <a:spLocks noGrp="1"/>
           </p:cNvSpPr>
           <p:nvPr>
             <p:ph type="sldImg" idx="2"/>
@@ -1214,7 +1420,7 @@
             <a:spLocks noGrp="1"/>
           </p:cNvSpPr>
           <p:nvPr>
-            <p:ph type="body" sz="quarter" idx="3"/>
+            <p:ph type="body" idx="3" sz="quarter"/>
           </p:nvPr>
         </p:nvSpPr>
         <p:spPr/>
@@ -1235,7 +1441,7 @@
             <a:spLocks noGrp="1"/>
           </p:cNvSpPr>
           <p:nvPr>
-            <p:ph type="sldNum" sz="quarter" idx="5"/>
+            <p:ph type="sldNum" idx="5" sz="quarter"/>
           </p:nvPr>
         </p:nvSpPr>
         <p:spPr/>
@@ -1249,7 +1455,7 @@
 </file>
 
 <file path=ppt/notesSlides/notesSlide6.xml><?xml version="1.0" encoding="utf-8"?>
-<p:notes xmlns:a="http://schemas.openxmlformats.org/drawingml/2006/main" xmlns:r="http://schemas.openxmlformats.org/officeDocument/2006/relationships" xmlns:p="http://schemas.openxmlformats.org/presentationml/2006/main">
+<p:notes xmlns:a="http://schemas.openxmlformats.org/drawingml/2006/main" xmlns:p="http://schemas.openxmlformats.org/presentationml/2006/main" xmlns:r="http://schemas.openxmlformats.org/officeDocument/2006/relationships">
   <p:cSld>
     <p:spTree>
       <p:nvGrpSpPr>
@@ -1269,7 +1475,7 @@
         <p:nvSpPr>
           <p:cNvPr id="2" name="Slide Image Placeholder 1"/>
           <p:cNvSpPr>
-            <a:spLocks noGrp="1" noRot="1" noChangeAspect="1"/>
+            <a:spLocks noGrp="1"/>
           </p:cNvSpPr>
           <p:nvPr>
             <p:ph type="sldImg" idx="2"/>
@@ -1284,7 +1490,7 @@
             <a:spLocks noGrp="1"/>
           </p:cNvSpPr>
           <p:nvPr>
-            <p:ph type="body" sz="quarter" idx="3"/>
+            <p:ph type="body" idx="3" sz="quarter"/>
           </p:nvPr>
         </p:nvSpPr>
         <p:spPr/>
@@ -1305,7 +1511,7 @@
             <a:spLocks noGrp="1"/>
           </p:cNvSpPr>
           <p:nvPr>
-            <p:ph type="sldNum" sz="quarter" idx="5"/>
+            <p:ph type="sldNum" idx="5" sz="quarter"/>
           </p:nvPr>
         </p:nvSpPr>
         <p:spPr/>
@@ -1319,7 +1525,7 @@
 </file>
 
 <file path=ppt/notesSlides/notesSlide7.xml><?xml version="1.0" encoding="utf-8"?>
-<p:notes xmlns:a="http://schemas.openxmlformats.org/drawingml/2006/main" xmlns:r="http://schemas.openxmlformats.org/officeDocument/2006/relationships" xmlns:p="http://schemas.openxmlformats.org/presentationml/2006/main">
+<p:notes xmlns:a="http://schemas.openxmlformats.org/drawingml/2006/main" xmlns:p="http://schemas.openxmlformats.org/presentationml/2006/main" xmlns:r="http://schemas.openxmlformats.org/officeDocument/2006/relationships">
   <p:cSld>
     <p:spTree>
       <p:nvGrpSpPr>
@@ -1339,7 +1545,7 @@
         <p:nvSpPr>
           <p:cNvPr id="2" name="Slide Image Placeholder 1"/>
           <p:cNvSpPr>
-            <a:spLocks noGrp="1" noRot="1" noChangeAspect="1"/>
+            <a:spLocks noGrp="1"/>
           </p:cNvSpPr>
           <p:nvPr>
             <p:ph type="sldImg" idx="2"/>
@@ -1354,7 +1560,7 @@
             <a:spLocks noGrp="1"/>
           </p:cNvSpPr>
           <p:nvPr>
-            <p:ph type="body" sz="quarter" idx="3"/>
+            <p:ph type="body" idx="3" sz="quarter"/>
           </p:nvPr>
         </p:nvSpPr>
         <p:spPr/>
@@ -1375,7 +1581,7 @@
             <a:spLocks noGrp="1"/>
           </p:cNvSpPr>
           <p:nvPr>
-            <p:ph type="sldNum" sz="quarter" idx="5"/>
+            <p:ph type="sldNum" idx="5" sz="quarter"/>
           </p:nvPr>
         </p:nvSpPr>
         <p:spPr/>
@@ -1389,7 +1595,7 @@
 </file>
 
 <file path=ppt/notesSlides/notesSlide8.xml><?xml version="1.0" encoding="utf-8"?>
-<p:notes xmlns:a="http://schemas.openxmlformats.org/drawingml/2006/main" xmlns:r="http://schemas.openxmlformats.org/officeDocument/2006/relationships" xmlns:p="http://schemas.openxmlformats.org/presentationml/2006/main">
+<p:notes xmlns:a="http://schemas.openxmlformats.org/drawingml/2006/main" xmlns:p="http://schemas.openxmlformats.org/presentationml/2006/main" xmlns:r="http://schemas.openxmlformats.org/officeDocument/2006/relationships">
   <p:cSld>
     <p:spTree>
       <p:nvGrpSpPr>
@@ -1409,7 +1615,7 @@
         <p:nvSpPr>
           <p:cNvPr id="2" name="Slide Image Placeholder 1"/>
           <p:cNvSpPr>
-            <a:spLocks noGrp="1" noRot="1" noChangeAspect="1"/>
+            <a:spLocks noGrp="1"/>
           </p:cNvSpPr>
           <p:nvPr>
             <p:ph type="sldImg" idx="2"/>
@@ -1424,7 +1630,7 @@
             <a:spLocks noGrp="1"/>
           </p:cNvSpPr>
           <p:nvPr>
-            <p:ph type="body" sz="quarter" idx="3"/>
+            <p:ph type="body" idx="3" sz="quarter"/>
           </p:nvPr>
         </p:nvSpPr>
         <p:spPr/>
@@ -1445,7 +1651,7 @@
             <a:spLocks noGrp="1"/>
           </p:cNvSpPr>
           <p:nvPr>
-            <p:ph type="sldNum" sz="quarter" idx="5"/>
+            <p:ph type="sldNum" idx="5" sz="quarter"/>
           </p:nvPr>
         </p:nvSpPr>
         <p:spPr/>
@@ -1459,7 +1665,7 @@
 </file>
 
 <file path=ppt/notesSlides/notesSlide9.xml><?xml version="1.0" encoding="utf-8"?>
-<p:notes xmlns:a="http://schemas.openxmlformats.org/drawingml/2006/main" xmlns:r="http://schemas.openxmlformats.org/officeDocument/2006/relationships" xmlns:p="http://schemas.openxmlformats.org/presentationml/2006/main">
+<p:notes xmlns:a="http://schemas.openxmlformats.org/drawingml/2006/main" xmlns:p="http://schemas.openxmlformats.org/presentationml/2006/main" xmlns:r="http://schemas.openxmlformats.org/officeDocument/2006/relationships">
   <p:cSld>
     <p:spTree>
       <p:nvGrpSpPr>
@@ -1479,7 +1685,7 @@
         <p:nvSpPr>
           <p:cNvPr id="2" name="Slide Image Placeholder 1"/>
           <p:cNvSpPr>
-            <a:spLocks noGrp="1" noRot="1" noChangeAspect="1"/>
+            <a:spLocks noGrp="1"/>
           </p:cNvSpPr>
           <p:nvPr>
             <p:ph type="sldImg" idx="2"/>
@@ -1494,7 +1700,7 @@
             <a:spLocks noGrp="1"/>
           </p:cNvSpPr>
           <p:nvPr>
-            <p:ph type="body" sz="quarter" idx="3"/>
+            <p:ph type="body" idx="3" sz="quarter"/>
           </p:nvPr>
         </p:nvSpPr>
         <p:spPr/>
@@ -1503,7 +1709,7 @@
           <a:lstStyle/>
           <a:p>
             <a:r>
-              <a:t>Highlight why ticket size matters: leading with GHS 1,200 orders yields ~GHS 23 net margin and drops monthly break-even from 63 to just 22 transactions.</a:t>
+              <a:t>Say the uncomfortable part first: MoMo collection costs 1.95% and each payout GHS 1.00, so a 2% fee would lose GHS 4-7 on every order. At 4% all-in (2.5% vendor + 1.5% buyer protection fee) net is 1.29% on a GHS 800 order. Against a fully staffed month-36 cost base of GHS 637k/month, company break-even is ~62,000 orders/month. Levers: a 5% fee (~34,800), direct telco rails via our own PSP licence (~34,500), high-ticket vendors (~37,900 at GHS 1,200). Buyer acceptance of the 1.5% fee is the first thing the pilot tests.</a:t>
             </a:r>
           </a:p>
         </p:txBody>
@@ -1515,7 +1721,7 @@
             <a:spLocks noGrp="1"/>
           </p:cNvSpPr>
           <p:nvPr>
-            <p:ph type="sldNum" sz="quarter" idx="5"/>
+            <p:ph type="sldNum" idx="5" sz="quarter"/>
           </p:nvPr>
         </p:nvSpPr>
         <p:spPr/>
@@ -1566,9 +1772,10 @@
           <a:lstStyle/>
           <a:p>
             <a:r>
-              <a:rPr lang="en-US"/>
+              <a:rPr lang="en-US" smtClean="0"/>
               <a:t>Click to edit Master title style</a:t>
             </a:r>
+            <a:endParaRPr lang="en-US"/>
           </a:p>
         </p:txBody>
       </p:sp>
@@ -1684,9 +1891,10 @@
           </a:lstStyle>
           <a:p>
             <a:r>
-              <a:rPr lang="en-US"/>
+              <a:rPr lang="en-US" smtClean="0"/>
               <a:t>Click to edit Master subtitle style</a:t>
             </a:r>
+            <a:endParaRPr lang="en-US"/>
           </a:p>
         </p:txBody>
       </p:sp>
@@ -1707,7 +1915,7 @@
           <a:p>
             <a:fld id="{5BCAD085-E8A6-8845-BD4E-CB4CCA059FC4}" type="datetimeFigureOut">
               <a:rPr lang="en-US" smtClean="0"/>
-              <a:t>9/23/2026</a:t>
+              <a:t>1/27/13</a:t>
             </a:fld>
             <a:endParaRPr lang="en-US"/>
           </a:p>
@@ -1801,9 +2009,10 @@
           <a:lstStyle/>
           <a:p>
             <a:r>
-              <a:rPr lang="en-US"/>
+              <a:rPr lang="en-US" smtClean="0"/>
               <a:t>Click to edit Master title style</a:t>
             </a:r>
+            <a:endParaRPr lang="en-US"/>
           </a:p>
         </p:txBody>
       </p:sp>
@@ -1824,37 +2033,38 @@
           <a:p>
             <a:pPr lvl="0"/>
             <a:r>
-              <a:rPr lang="en-US"/>
+              <a:rPr lang="en-US" smtClean="0"/>
               <a:t>Click to edit Master text styles</a:t>
             </a:r>
           </a:p>
           <a:p>
             <a:pPr lvl="1"/>
             <a:r>
-              <a:rPr lang="en-US"/>
+              <a:rPr lang="en-US" smtClean="0"/>
               <a:t>Second level</a:t>
             </a:r>
           </a:p>
           <a:p>
             <a:pPr lvl="2"/>
             <a:r>
-              <a:rPr lang="en-US"/>
+              <a:rPr lang="en-US" smtClean="0"/>
               <a:t>Third level</a:t>
             </a:r>
           </a:p>
           <a:p>
             <a:pPr lvl="3"/>
             <a:r>
-              <a:rPr lang="en-US"/>
+              <a:rPr lang="en-US" smtClean="0"/>
               <a:t>Fourth level</a:t>
             </a:r>
           </a:p>
           <a:p>
             <a:pPr lvl="4"/>
             <a:r>
-              <a:rPr lang="en-US"/>
+              <a:rPr lang="en-US" smtClean="0"/>
               <a:t>Fifth level</a:t>
             </a:r>
+            <a:endParaRPr lang="en-US"/>
           </a:p>
         </p:txBody>
       </p:sp>
@@ -1875,7 +2085,7 @@
           <a:p>
             <a:fld id="{5BCAD085-E8A6-8845-BD4E-CB4CCA059FC4}" type="datetimeFigureOut">
               <a:rPr lang="en-US" smtClean="0"/>
-              <a:t>9/23/2026</a:t>
+              <a:t>1/27/13</a:t>
             </a:fld>
             <a:endParaRPr lang="en-US"/>
           </a:p>
@@ -1974,9 +2184,10 @@
           <a:lstStyle/>
           <a:p>
             <a:r>
-              <a:rPr lang="en-US"/>
+              <a:rPr lang="en-US" smtClean="0"/>
               <a:t>Click to edit Master title style</a:t>
             </a:r>
+            <a:endParaRPr lang="en-US"/>
           </a:p>
         </p:txBody>
       </p:sp>
@@ -2002,37 +2213,38 @@
           <a:p>
             <a:pPr lvl="0"/>
             <a:r>
-              <a:rPr lang="en-US"/>
+              <a:rPr lang="en-US" smtClean="0"/>
               <a:t>Click to edit Master text styles</a:t>
             </a:r>
           </a:p>
           <a:p>
             <a:pPr lvl="1"/>
             <a:r>
-              <a:rPr lang="en-US"/>
+              <a:rPr lang="en-US" smtClean="0"/>
               <a:t>Second level</a:t>
             </a:r>
           </a:p>
           <a:p>
             <a:pPr lvl="2"/>
             <a:r>
-              <a:rPr lang="en-US"/>
+              <a:rPr lang="en-US" smtClean="0"/>
               <a:t>Third level</a:t>
             </a:r>
           </a:p>
           <a:p>
             <a:pPr lvl="3"/>
             <a:r>
-              <a:rPr lang="en-US"/>
+              <a:rPr lang="en-US" smtClean="0"/>
               <a:t>Fourth level</a:t>
             </a:r>
           </a:p>
           <a:p>
             <a:pPr lvl="4"/>
             <a:r>
-              <a:rPr lang="en-US"/>
+              <a:rPr lang="en-US" smtClean="0"/>
               <a:t>Fifth level</a:t>
             </a:r>
+            <a:endParaRPr lang="en-US"/>
           </a:p>
         </p:txBody>
       </p:sp>
@@ -2053,7 +2265,7 @@
           <a:p>
             <a:fld id="{5BCAD085-E8A6-8845-BD4E-CB4CCA059FC4}" type="datetimeFigureOut">
               <a:rPr lang="en-US" smtClean="0"/>
-              <a:t>9/23/2026</a:t>
+              <a:t>1/27/13</a:t>
             </a:fld>
             <a:endParaRPr lang="en-US"/>
           </a:p>
@@ -2147,9 +2359,10 @@
           <a:lstStyle/>
           <a:p>
             <a:r>
-              <a:rPr lang="en-US"/>
+              <a:rPr lang="en-US" smtClean="0"/>
               <a:t>Click to edit Master title style</a:t>
             </a:r>
+            <a:endParaRPr lang="en-US"/>
           </a:p>
         </p:txBody>
       </p:sp>
@@ -2170,37 +2383,38 @@
           <a:p>
             <a:pPr lvl="0"/>
             <a:r>
-              <a:rPr lang="en-US"/>
+              <a:rPr lang="en-US" smtClean="0"/>
               <a:t>Click to edit Master text styles</a:t>
             </a:r>
           </a:p>
           <a:p>
             <a:pPr lvl="1"/>
             <a:r>
-              <a:rPr lang="en-US"/>
+              <a:rPr lang="en-US" smtClean="0"/>
               <a:t>Second level</a:t>
             </a:r>
           </a:p>
           <a:p>
             <a:pPr lvl="2"/>
             <a:r>
-              <a:rPr lang="en-US"/>
+              <a:rPr lang="en-US" smtClean="0"/>
               <a:t>Third level</a:t>
             </a:r>
           </a:p>
           <a:p>
             <a:pPr lvl="3"/>
             <a:r>
-              <a:rPr lang="en-US"/>
+              <a:rPr lang="en-US" smtClean="0"/>
               <a:t>Fourth level</a:t>
             </a:r>
           </a:p>
           <a:p>
             <a:pPr lvl="4"/>
             <a:r>
-              <a:rPr lang="en-US"/>
+              <a:rPr lang="en-US" smtClean="0"/>
               <a:t>Fifth level</a:t>
             </a:r>
+            <a:endParaRPr lang="en-US"/>
           </a:p>
         </p:txBody>
       </p:sp>
@@ -2221,7 +2435,7 @@
           <a:p>
             <a:fld id="{5BCAD085-E8A6-8845-BD4E-CB4CCA059FC4}" type="datetimeFigureOut">
               <a:rPr lang="en-US" smtClean="0"/>
-              <a:t>9/23/2026</a:t>
+              <a:t>1/27/13</a:t>
             </a:fld>
             <a:endParaRPr lang="en-US"/>
           </a:p>
@@ -2324,9 +2538,10 @@
           </a:lstStyle>
           <a:p>
             <a:r>
-              <a:rPr lang="en-US"/>
+              <a:rPr lang="en-US" smtClean="0"/>
               <a:t>Click to edit Master title style</a:t>
             </a:r>
+            <a:endParaRPr lang="en-US"/>
           </a:p>
         </p:txBody>
       </p:sp>
@@ -2443,7 +2658,7 @@
           <a:p>
             <a:pPr lvl="0"/>
             <a:r>
-              <a:rPr lang="en-US"/>
+              <a:rPr lang="en-US" smtClean="0"/>
               <a:t>Click to edit Master text styles</a:t>
             </a:r>
           </a:p>
@@ -2466,7 +2681,7 @@
           <a:p>
             <a:fld id="{5BCAD085-E8A6-8845-BD4E-CB4CCA059FC4}" type="datetimeFigureOut">
               <a:rPr lang="en-US" smtClean="0"/>
-              <a:t>9/23/2026</a:t>
+              <a:t>1/27/13</a:t>
             </a:fld>
             <a:endParaRPr lang="en-US"/>
           </a:p>
@@ -2560,9 +2775,10 @@
           <a:lstStyle/>
           <a:p>
             <a:r>
-              <a:rPr lang="en-US"/>
+              <a:rPr lang="en-US" smtClean="0"/>
               <a:t>Click to edit Master title style</a:t>
             </a:r>
+            <a:endParaRPr lang="en-US"/>
           </a:p>
         </p:txBody>
       </p:sp>
@@ -2616,37 +2832,38 @@
           <a:p>
             <a:pPr lvl="0"/>
             <a:r>
-              <a:rPr lang="en-US"/>
+              <a:rPr lang="en-US" smtClean="0"/>
               <a:t>Click to edit Master text styles</a:t>
             </a:r>
           </a:p>
           <a:p>
             <a:pPr lvl="1"/>
             <a:r>
-              <a:rPr lang="en-US"/>
+              <a:rPr lang="en-US" smtClean="0"/>
               <a:t>Second level</a:t>
             </a:r>
           </a:p>
           <a:p>
             <a:pPr lvl="2"/>
             <a:r>
-              <a:rPr lang="en-US"/>
+              <a:rPr lang="en-US" smtClean="0"/>
               <a:t>Third level</a:t>
             </a:r>
           </a:p>
           <a:p>
             <a:pPr lvl="3"/>
             <a:r>
-              <a:rPr lang="en-US"/>
+              <a:rPr lang="en-US" smtClean="0"/>
               <a:t>Fourth level</a:t>
             </a:r>
           </a:p>
           <a:p>
             <a:pPr lvl="4"/>
             <a:r>
-              <a:rPr lang="en-US"/>
+              <a:rPr lang="en-US" smtClean="0"/>
               <a:t>Fifth level</a:t>
             </a:r>
+            <a:endParaRPr lang="en-US"/>
           </a:p>
         </p:txBody>
       </p:sp>
@@ -2700,37 +2917,38 @@
           <a:p>
             <a:pPr lvl="0"/>
             <a:r>
-              <a:rPr lang="en-US"/>
+              <a:rPr lang="en-US" smtClean="0"/>
               <a:t>Click to edit Master text styles</a:t>
             </a:r>
           </a:p>
           <a:p>
             <a:pPr lvl="1"/>
             <a:r>
-              <a:rPr lang="en-US"/>
+              <a:rPr lang="en-US" smtClean="0"/>
               <a:t>Second level</a:t>
             </a:r>
           </a:p>
           <a:p>
             <a:pPr lvl="2"/>
             <a:r>
-              <a:rPr lang="en-US"/>
+              <a:rPr lang="en-US" smtClean="0"/>
               <a:t>Third level</a:t>
             </a:r>
           </a:p>
           <a:p>
             <a:pPr lvl="3"/>
             <a:r>
-              <a:rPr lang="en-US"/>
+              <a:rPr lang="en-US" smtClean="0"/>
               <a:t>Fourth level</a:t>
             </a:r>
           </a:p>
           <a:p>
             <a:pPr lvl="4"/>
             <a:r>
-              <a:rPr lang="en-US"/>
+              <a:rPr lang="en-US" smtClean="0"/>
               <a:t>Fifth level</a:t>
             </a:r>
+            <a:endParaRPr lang="en-US"/>
           </a:p>
         </p:txBody>
       </p:sp>
@@ -2751,7 +2969,7 @@
           <a:p>
             <a:fld id="{5BCAD085-E8A6-8845-BD4E-CB4CCA059FC4}" type="datetimeFigureOut">
               <a:rPr lang="en-US" smtClean="0"/>
-              <a:t>9/23/2026</a:t>
+              <a:t>1/27/13</a:t>
             </a:fld>
             <a:endParaRPr lang="en-US"/>
           </a:p>
@@ -2849,9 +3067,10 @@
           </a:lstStyle>
           <a:p>
             <a:r>
-              <a:rPr lang="en-US"/>
+              <a:rPr lang="en-US" smtClean="0"/>
               <a:t>Click to edit Master title style</a:t>
             </a:r>
+            <a:endParaRPr lang="en-US"/>
           </a:p>
         </p:txBody>
       </p:sp>
@@ -2914,7 +3133,7 @@
           <a:p>
             <a:pPr lvl="0"/>
             <a:r>
-              <a:rPr lang="en-US"/>
+              <a:rPr lang="en-US" smtClean="0"/>
               <a:t>Click to edit Master text styles</a:t>
             </a:r>
           </a:p>
@@ -2970,37 +3189,38 @@
           <a:p>
             <a:pPr lvl="0"/>
             <a:r>
-              <a:rPr lang="en-US"/>
+              <a:rPr lang="en-US" smtClean="0"/>
               <a:t>Click to edit Master text styles</a:t>
             </a:r>
           </a:p>
           <a:p>
             <a:pPr lvl="1"/>
             <a:r>
-              <a:rPr lang="en-US"/>
+              <a:rPr lang="en-US" smtClean="0"/>
               <a:t>Second level</a:t>
             </a:r>
           </a:p>
           <a:p>
             <a:pPr lvl="2"/>
             <a:r>
-              <a:rPr lang="en-US"/>
+              <a:rPr lang="en-US" smtClean="0"/>
               <a:t>Third level</a:t>
             </a:r>
           </a:p>
           <a:p>
             <a:pPr lvl="3"/>
             <a:r>
-              <a:rPr lang="en-US"/>
+              <a:rPr lang="en-US" smtClean="0"/>
               <a:t>Fourth level</a:t>
             </a:r>
           </a:p>
           <a:p>
             <a:pPr lvl="4"/>
             <a:r>
-              <a:rPr lang="en-US"/>
+              <a:rPr lang="en-US" smtClean="0"/>
               <a:t>Fifth level</a:t>
             </a:r>
+            <a:endParaRPr lang="en-US"/>
           </a:p>
         </p:txBody>
       </p:sp>
@@ -3063,7 +3283,7 @@
           <a:p>
             <a:pPr lvl="0"/>
             <a:r>
-              <a:rPr lang="en-US"/>
+              <a:rPr lang="en-US" smtClean="0"/>
               <a:t>Click to edit Master text styles</a:t>
             </a:r>
           </a:p>
@@ -3119,37 +3339,38 @@
           <a:p>
             <a:pPr lvl="0"/>
             <a:r>
-              <a:rPr lang="en-US"/>
+              <a:rPr lang="en-US" smtClean="0"/>
               <a:t>Click to edit Master text styles</a:t>
             </a:r>
           </a:p>
           <a:p>
             <a:pPr lvl="1"/>
             <a:r>
-              <a:rPr lang="en-US"/>
+              <a:rPr lang="en-US" smtClean="0"/>
               <a:t>Second level</a:t>
             </a:r>
           </a:p>
           <a:p>
             <a:pPr lvl="2"/>
             <a:r>
-              <a:rPr lang="en-US"/>
+              <a:rPr lang="en-US" smtClean="0"/>
               <a:t>Third level</a:t>
             </a:r>
           </a:p>
           <a:p>
             <a:pPr lvl="3"/>
             <a:r>
-              <a:rPr lang="en-US"/>
+              <a:rPr lang="en-US" smtClean="0"/>
               <a:t>Fourth level</a:t>
             </a:r>
           </a:p>
           <a:p>
             <a:pPr lvl="4"/>
             <a:r>
-              <a:rPr lang="en-US"/>
+              <a:rPr lang="en-US" smtClean="0"/>
               <a:t>Fifth level</a:t>
             </a:r>
+            <a:endParaRPr lang="en-US"/>
           </a:p>
         </p:txBody>
       </p:sp>
@@ -3170,7 +3391,7 @@
           <a:p>
             <a:fld id="{5BCAD085-E8A6-8845-BD4E-CB4CCA059FC4}" type="datetimeFigureOut">
               <a:rPr lang="en-US" smtClean="0"/>
-              <a:t>9/23/2026</a:t>
+              <a:t>1/27/13</a:t>
             </a:fld>
             <a:endParaRPr lang="en-US"/>
           </a:p>
@@ -3264,9 +3485,10 @@
           <a:lstStyle/>
           <a:p>
             <a:r>
-              <a:rPr lang="en-US"/>
+              <a:rPr lang="en-US" smtClean="0"/>
               <a:t>Click to edit Master title style</a:t>
             </a:r>
+            <a:endParaRPr lang="en-US"/>
           </a:p>
         </p:txBody>
       </p:sp>
@@ -3287,7 +3509,7 @@
           <a:p>
             <a:fld id="{5BCAD085-E8A6-8845-BD4E-CB4CCA059FC4}" type="datetimeFigureOut">
               <a:rPr lang="en-US" smtClean="0"/>
-              <a:t>9/23/2026</a:t>
+              <a:t>1/27/13</a:t>
             </a:fld>
             <a:endParaRPr lang="en-US"/>
           </a:p>
@@ -3382,7 +3604,7 @@
           <a:p>
             <a:fld id="{5BCAD085-E8A6-8845-BD4E-CB4CCA059FC4}" type="datetimeFigureOut">
               <a:rPr lang="en-US" smtClean="0"/>
-              <a:t>9/23/2026</a:t>
+              <a:t>1/27/13</a:t>
             </a:fld>
             <a:endParaRPr lang="en-US"/>
           </a:p>
@@ -3485,9 +3707,10 @@
           </a:lstStyle>
           <a:p>
             <a:r>
-              <a:rPr lang="en-US"/>
+              <a:rPr lang="en-US" smtClean="0"/>
               <a:t>Click to edit Master title style</a:t>
             </a:r>
+            <a:endParaRPr lang="en-US"/>
           </a:p>
         </p:txBody>
       </p:sp>
@@ -3541,37 +3764,38 @@
           <a:p>
             <a:pPr lvl="0"/>
             <a:r>
-              <a:rPr lang="en-US"/>
+              <a:rPr lang="en-US" smtClean="0"/>
               <a:t>Click to edit Master text styles</a:t>
             </a:r>
           </a:p>
           <a:p>
             <a:pPr lvl="1"/>
             <a:r>
-              <a:rPr lang="en-US"/>
+              <a:rPr lang="en-US" smtClean="0"/>
               <a:t>Second level</a:t>
             </a:r>
           </a:p>
           <a:p>
             <a:pPr lvl="2"/>
             <a:r>
-              <a:rPr lang="en-US"/>
+              <a:rPr lang="en-US" smtClean="0"/>
               <a:t>Third level</a:t>
             </a:r>
           </a:p>
           <a:p>
             <a:pPr lvl="3"/>
             <a:r>
-              <a:rPr lang="en-US"/>
+              <a:rPr lang="en-US" smtClean="0"/>
               <a:t>Fourth level</a:t>
             </a:r>
           </a:p>
           <a:p>
             <a:pPr lvl="4"/>
             <a:r>
-              <a:rPr lang="en-US"/>
+              <a:rPr lang="en-US" smtClean="0"/>
               <a:t>Fifth level</a:t>
             </a:r>
+            <a:endParaRPr lang="en-US"/>
           </a:p>
         </p:txBody>
       </p:sp>
@@ -3634,7 +3858,7 @@
           <a:p>
             <a:pPr lvl="0"/>
             <a:r>
-              <a:rPr lang="en-US"/>
+              <a:rPr lang="en-US" smtClean="0"/>
               <a:t>Click to edit Master text styles</a:t>
             </a:r>
           </a:p>
@@ -3657,7 +3881,7 @@
           <a:p>
             <a:fld id="{5BCAD085-E8A6-8845-BD4E-CB4CCA059FC4}" type="datetimeFigureOut">
               <a:rPr lang="en-US" smtClean="0"/>
-              <a:t>9/23/2026</a:t>
+              <a:t>1/27/13</a:t>
             </a:fld>
             <a:endParaRPr lang="en-US"/>
           </a:p>
@@ -3760,9 +3984,10 @@
           </a:lstStyle>
           <a:p>
             <a:r>
-              <a:rPr lang="en-US"/>
+              <a:rPr lang="en-US" smtClean="0"/>
               <a:t>Click to edit Master title style</a:t>
             </a:r>
+            <a:endParaRPr lang="en-US"/>
           </a:p>
         </p:txBody>
       </p:sp>
@@ -3886,7 +4111,7 @@
           <a:p>
             <a:pPr lvl="0"/>
             <a:r>
-              <a:rPr lang="en-US"/>
+              <a:rPr lang="en-US" smtClean="0"/>
               <a:t>Click to edit Master text styles</a:t>
             </a:r>
           </a:p>
@@ -3909,7 +4134,7 @@
           <a:p>
             <a:fld id="{5BCAD085-E8A6-8845-BD4E-CB4CCA059FC4}" type="datetimeFigureOut">
               <a:rPr lang="en-US" smtClean="0"/>
-              <a:t>9/23/2026</a:t>
+              <a:t>1/27/13</a:t>
             </a:fld>
             <a:endParaRPr lang="en-US"/>
           </a:p>
@@ -4018,9 +4243,10 @@
           <a:lstStyle/>
           <a:p>
             <a:r>
-              <a:rPr lang="en-US"/>
+              <a:rPr lang="en-US" smtClean="0"/>
               <a:t>Click to edit Master title style</a:t>
             </a:r>
+            <a:endParaRPr lang="en-US"/>
           </a:p>
         </p:txBody>
       </p:sp>
@@ -4051,37 +4277,38 @@
           <a:p>
             <a:pPr lvl="0"/>
             <a:r>
-              <a:rPr lang="en-US"/>
+              <a:rPr lang="en-US" smtClean="0"/>
               <a:t>Click to edit Master text styles</a:t>
             </a:r>
           </a:p>
           <a:p>
             <a:pPr lvl="1"/>
             <a:r>
-              <a:rPr lang="en-US"/>
+              <a:rPr lang="en-US" smtClean="0"/>
               <a:t>Second level</a:t>
             </a:r>
           </a:p>
           <a:p>
             <a:pPr lvl="2"/>
             <a:r>
-              <a:rPr lang="en-US"/>
+              <a:rPr lang="en-US" smtClean="0"/>
               <a:t>Third level</a:t>
             </a:r>
           </a:p>
           <a:p>
             <a:pPr lvl="3"/>
             <a:r>
-              <a:rPr lang="en-US"/>
+              <a:rPr lang="en-US" smtClean="0"/>
               <a:t>Fourth level</a:t>
             </a:r>
           </a:p>
           <a:p>
             <a:pPr lvl="4"/>
             <a:r>
-              <a:rPr lang="en-US"/>
+              <a:rPr lang="en-US" smtClean="0"/>
               <a:t>Fifth level</a:t>
             </a:r>
+            <a:endParaRPr lang="en-US"/>
           </a:p>
         </p:txBody>
       </p:sp>
@@ -4120,7 +4347,7 @@
           <a:p>
             <a:fld id="{5BCAD085-E8A6-8845-BD4E-CB4CCA059FC4}" type="datetimeFigureOut">
               <a:rPr lang="en-US" smtClean="0"/>
-              <a:t>9/23/2026</a:t>
+              <a:t>1/27/13</a:t>
             </a:fld>
             <a:endParaRPr lang="en-US"/>
           </a:p>
@@ -4479,7 +4706,7 @@
 </file>
 
 <file path=ppt/slides/slide1.xml><?xml version="1.0" encoding="utf-8"?>
-<p:sld xmlns:a="http://schemas.openxmlformats.org/drawingml/2006/main" xmlns:r="http://schemas.openxmlformats.org/officeDocument/2006/relationships" xmlns:p="http://schemas.openxmlformats.org/presentationml/2006/main">
+<p:sld xmlns:a="http://schemas.openxmlformats.org/drawingml/2006/main" xmlns:p="http://schemas.openxmlformats.org/presentationml/2006/main" xmlns:r="http://schemas.openxmlformats.org/officeDocument/2006/relationships">
   <p:cSld>
     <p:spTree>
       <p:nvGrpSpPr>
@@ -4487,14 +4714,7 @@
         <p:cNvGrpSpPr/>
         <p:nvPr/>
       </p:nvGrpSpPr>
-      <p:grpSpPr>
-        <a:xfrm>
-          <a:off x="0" y="0"/>
-          <a:ext cx="0" cy="0"/>
-          <a:chOff x="0" y="0"/>
-          <a:chExt cx="0" cy="0"/>
-        </a:xfrm>
-      </p:grpSpPr>
+      <p:grpSpPr/>
       <p:sp>
         <p:nvSpPr>
           <p:cNvPr id="2" name="Rectangle 1"/>
@@ -4535,7 +4755,6 @@
           <a:lstStyle/>
           <a:p>
             <a:pPr algn="ctr"/>
-            <a:endParaRPr/>
           </a:p>
         </p:txBody>
       </p:sp>
@@ -4548,7 +4767,7 @@
           <p:nvPr/>
         </p:nvPicPr>
         <p:blipFill>
-          <a:blip r:embed="rId3"/>
+          <a:blip r:embed="rId2"/>
           <a:stretch>
             <a:fillRect/>
           </a:stretch>
@@ -4624,7 +4843,7 @@
         <p:spPr>
           <a:xfrm>
             <a:off x="1051560" y="5486400"/>
-            <a:ext cx="7454926" cy="307777"/>
+            <a:ext cx="9326880" cy="457200"/>
           </a:xfrm>
           <a:prstGeom prst="rect">
             <a:avLst/>
@@ -4646,16 +4865,7 @@
               </a:defRPr>
             </a:pPr>
             <a:r>
-              <a:rPr dirty="0"/>
-              <a:t>Found</a:t>
-            </a:r>
-            <a:r>
-              <a:rPr lang="en-US" dirty="0"/>
-              <a:t>er: Jerry Amoah (amoahjerry835@gmail.com)</a:t>
-            </a:r>
-            <a:r>
-              <a:rPr dirty="0"/>
-              <a:t>  ·  Accra, Ghana  ·  Pre-Seed / Pilot Stage</a:t>
+              <a:t>Founding Team  ·  founders@croe.app  ·  Accra, Ghana  ·  Pre-Seed / Pilot Stage</a:t>
             </a:r>
           </a:p>
         </p:txBody>
@@ -4669,7 +4879,7 @@
 </file>
 
 <file path=ppt/slides/slide10.xml><?xml version="1.0" encoding="utf-8"?>
-<p:sld xmlns:a="http://schemas.openxmlformats.org/drawingml/2006/main" xmlns:r="http://schemas.openxmlformats.org/officeDocument/2006/relationships" xmlns:p="http://schemas.openxmlformats.org/presentationml/2006/main">
+<p:sld xmlns:a="http://schemas.openxmlformats.org/drawingml/2006/main" xmlns:p="http://schemas.openxmlformats.org/presentationml/2006/main" xmlns:r="http://schemas.openxmlformats.org/officeDocument/2006/relationships">
   <p:cSld>
     <p:spTree>
       <p:nvGrpSpPr>
@@ -4677,14 +4887,7 @@
         <p:cNvGrpSpPr/>
         <p:nvPr/>
       </p:nvGrpSpPr>
-      <p:grpSpPr>
-        <a:xfrm>
-          <a:off x="0" y="0"/>
-          <a:ext cx="0" cy="0"/>
-          <a:chOff x="0" y="0"/>
-          <a:chExt cx="0" cy="0"/>
-        </a:xfrm>
-      </p:grpSpPr>
+      <p:grpSpPr/>
       <p:sp>
         <p:nvSpPr>
           <p:cNvPr id="2" name="Rectangle 1"/>
@@ -4725,7 +4928,6 @@
           <a:lstStyle/>
           <a:p>
             <a:pPr algn="ctr"/>
-            <a:endParaRPr/>
           </a:p>
         </p:txBody>
       </p:sp>
@@ -4841,7 +5043,6 @@
           <a:lstStyle/>
           <a:p>
             <a:pPr algn="ctr"/>
-            <a:endParaRPr/>
           </a:p>
         </p:txBody>
       </p:sp>
@@ -4854,7 +5055,7 @@
           <p:nvPr/>
         </p:nvPicPr>
         <p:blipFill>
-          <a:blip r:embed="rId3"/>
+          <a:blip r:embed="rId2"/>
           <a:stretch>
             <a:fillRect/>
           </a:stretch>
@@ -4892,7 +5093,7 @@
           <a:lstStyle/>
           <a:p>
             <a:pPr>
-              <a:defRPr sz="2000" b="1">
+              <a:defRPr b="1" sz="2000">
                 <a:solidFill>
                   <a:srgbClr val="0F172A"/>
                 </a:solidFill>
@@ -4907,7 +5108,7 @@
               <a:spcBef>
                 <a:spcPts val="800"/>
               </a:spcBef>
-              <a:defRPr sz="1300" b="1">
+              <a:defRPr b="1" sz="1300">
                 <a:solidFill>
                   <a:srgbClr val="2563EB"/>
                 </a:solidFill>
@@ -4957,7 +5158,7 @@
           <a:lstStyle/>
           <a:p>
             <a:pPr>
-              <a:defRPr sz="2000" b="1">
+              <a:defRPr b="1" sz="2000">
                 <a:solidFill>
                   <a:srgbClr val="0F172A"/>
                 </a:solidFill>
@@ -4972,7 +5173,7 @@
               <a:spcBef>
                 <a:spcPts val="800"/>
               </a:spcBef>
-              <a:defRPr sz="1300" b="1">
+              <a:defRPr b="1" sz="1300">
                 <a:solidFill>
                   <a:srgbClr val="1FC16B"/>
                 </a:solidFill>
@@ -5022,7 +5223,7 @@
           <a:lstStyle/>
           <a:p>
             <a:pPr>
-              <a:defRPr sz="2000" b="1">
+              <a:defRPr b="1" sz="2000">
                 <a:solidFill>
                   <a:srgbClr val="0F172A"/>
                 </a:solidFill>
@@ -5037,7 +5238,7 @@
               <a:spcBef>
                 <a:spcPts val="800"/>
               </a:spcBef>
-              <a:defRPr sz="1300" b="1">
+              <a:defRPr b="1" sz="1300">
                 <a:solidFill>
                   <a:srgbClr val="64748B"/>
                 </a:solidFill>
@@ -5087,7 +5288,7 @@
           <a:lstStyle/>
           <a:p>
             <a:pPr>
-              <a:defRPr sz="1200" b="1">
+              <a:defRPr b="1" sz="1200">
                 <a:solidFill>
                   <a:srgbClr val="1FC16B"/>
                 </a:solidFill>
@@ -5099,7 +5300,7 @@
           </a:p>
           <a:p>
             <a:pPr>
-              <a:defRPr sz="2200" b="1">
+              <a:defRPr b="1" sz="2200">
                 <a:solidFill>
                   <a:srgbClr val="0F172A"/>
                 </a:solidFill>
@@ -5121,7 +5322,7 @@
 </file>
 
 <file path=ppt/slides/slide11.xml><?xml version="1.0" encoding="utf-8"?>
-<p:sld xmlns:a="http://schemas.openxmlformats.org/drawingml/2006/main" xmlns:r="http://schemas.openxmlformats.org/officeDocument/2006/relationships" xmlns:p="http://schemas.openxmlformats.org/presentationml/2006/main">
+<p:sld xmlns:a="http://schemas.openxmlformats.org/drawingml/2006/main" xmlns:p="http://schemas.openxmlformats.org/presentationml/2006/main" xmlns:r="http://schemas.openxmlformats.org/officeDocument/2006/relationships">
   <p:cSld>
     <p:spTree>
       <p:nvGrpSpPr>
@@ -5129,14 +5330,7 @@
         <p:cNvGrpSpPr/>
         <p:nvPr/>
       </p:nvGrpSpPr>
-      <p:grpSpPr>
-        <a:xfrm>
-          <a:off x="0" y="0"/>
-          <a:ext cx="0" cy="0"/>
-          <a:chOff x="0" y="0"/>
-          <a:chExt cx="0" cy="0"/>
-        </a:xfrm>
-      </p:grpSpPr>
+      <p:grpSpPr/>
       <p:sp>
         <p:nvSpPr>
           <p:cNvPr id="2" name="Rectangle 1"/>
@@ -5177,7 +5371,6 @@
           <a:lstStyle/>
           <a:p>
             <a:pPr algn="ctr"/>
-            <a:endParaRPr/>
           </a:p>
         </p:txBody>
       </p:sp>
@@ -5293,7 +5486,6 @@
           <a:lstStyle/>
           <a:p>
             <a:pPr algn="ctr"/>
-            <a:endParaRPr/>
           </a:p>
         </p:txBody>
       </p:sp>
@@ -5306,7 +5498,7 @@
           <p:nvPr/>
         </p:nvPicPr>
         <p:blipFill>
-          <a:blip r:embed="rId3"/>
+          <a:blip r:embed="rId2"/>
           <a:stretch>
             <a:fillRect/>
           </a:stretch>
@@ -5344,7 +5536,7 @@
           <a:lstStyle/>
           <a:p>
             <a:pPr>
-              <a:defRPr sz="2000" b="1">
+              <a:defRPr b="1" sz="2000">
                 <a:solidFill>
                   <a:srgbClr val="2563EB"/>
                 </a:solidFill>
@@ -5471,7 +5663,6 @@
           <a:lstStyle/>
           <a:p>
             <a:pPr algn="ctr"/>
-            <a:endParaRPr/>
           </a:p>
         </p:txBody>
       </p:sp>
@@ -5498,14 +5689,14 @@
           <a:lstStyle/>
           <a:p>
             <a:pPr>
-              <a:defRPr sz="2000" b="1">
+              <a:defRPr b="1" sz="2000">
                 <a:solidFill>
                   <a:srgbClr val="0F172A"/>
                 </a:solidFill>
               </a:defRPr>
             </a:pPr>
             <a:r>
-              <a:t>60-Day Pilot Success Gates</a:t>
+              <a:t>Stage 1 Pilot Gates</a:t>
             </a:r>
           </a:p>
           <a:p>
@@ -5513,14 +5704,14 @@
               <a:spcBef>
                 <a:spcPts val="1200"/>
               </a:spcBef>
-              <a:defRPr sz="1400" b="1">
+              <a:defRPr b="1" sz="1400">
                 <a:solidFill>
                   <a:srgbClr val="0F172A"/>
                 </a:solidFill>
               </a:defRPr>
             </a:pPr>
             <a:r>
-              <a:t>Monthly Volume: ≥ 63 transactions</a:t>
+              <a:t>Volume: ≥ 250 orders by month 6</a:t>
             </a:r>
           </a:p>
           <a:p>
@@ -5532,7 +5723,7 @@
               </a:defRPr>
             </a:pPr>
             <a:r>
-              <a:t>  Clears the break-even hurdle</a:t>
+              <a:t>  Real demand on capped live rails</a:t>
             </a:r>
           </a:p>
           <a:p>
@@ -5540,7 +5731,7 @@
               <a:spcBef>
                 <a:spcPts val="1200"/>
               </a:spcBef>
-              <a:defRPr sz="1400" b="1">
+              <a:defRPr b="1" sz="1400">
                 <a:solidFill>
                   <a:srgbClr val="0F172A"/>
                 </a:solidFill>
@@ -5567,7 +5758,7 @@
               <a:spcBef>
                 <a:spcPts val="1200"/>
               </a:spcBef>
-              <a:defRPr sz="1400" b="1">
+              <a:defRPr b="1" sz="1400">
                 <a:solidFill>
                   <a:srgbClr val="0F172A"/>
                 </a:solidFill>
@@ -5594,14 +5785,14 @@
               <a:spcBef>
                 <a:spcPts val="1200"/>
               </a:spcBef>
-              <a:defRPr sz="1400" b="1">
+              <a:defRPr b="1" sz="1400">
                 <a:solidFill>
                   <a:srgbClr val="0F172A"/>
                 </a:solidFill>
               </a:defRPr>
             </a:pPr>
             <a:r>
-              <a:t>Buyer Drop-off: &lt; 30% drop-off</a:t>
+              <a:t>Buyer Drop-off: &lt; 30% with 1.5% fee shown</a:t>
             </a:r>
           </a:p>
           <a:p>
@@ -5613,7 +5804,7 @@
               </a:defRPr>
             </a:pPr>
             <a:r>
-              <a:t>  Validates mobile web/USSD UX</a:t>
+              <a:t>  Validates 4% pricing and web/USSD UX</a:t>
             </a:r>
           </a:p>
           <a:p>
@@ -5621,7 +5812,7 @@
               <a:spcBef>
                 <a:spcPts val="1200"/>
               </a:spcBef>
-              <a:defRPr sz="1400" b="1">
+              <a:defRPr b="1" sz="1400">
                 <a:solidFill>
                   <a:srgbClr val="0F172A"/>
                 </a:solidFill>
@@ -5648,7 +5839,7 @@
               <a:spcBef>
                 <a:spcPts val="1200"/>
               </a:spcBef>
-              <a:defRPr sz="1400" b="1">
+              <a:defRPr b="1" sz="1400">
                 <a:solidFill>
                   <a:srgbClr val="0F172A"/>
                 </a:solidFill>
@@ -5681,7 +5872,7 @@
 </file>
 
 <file path=ppt/slides/slide12.xml><?xml version="1.0" encoding="utf-8"?>
-<p:sld xmlns:a="http://schemas.openxmlformats.org/drawingml/2006/main" xmlns:r="http://schemas.openxmlformats.org/officeDocument/2006/relationships" xmlns:p="http://schemas.openxmlformats.org/presentationml/2006/main">
+<p:sld xmlns:a="http://schemas.openxmlformats.org/drawingml/2006/main" xmlns:p="http://schemas.openxmlformats.org/presentationml/2006/main" xmlns:r="http://schemas.openxmlformats.org/officeDocument/2006/relationships">
   <p:cSld>
     <p:spTree>
       <p:nvGrpSpPr>
@@ -5689,14 +5880,7 @@
         <p:cNvGrpSpPr/>
         <p:nvPr/>
       </p:nvGrpSpPr>
-      <p:grpSpPr>
-        <a:xfrm>
-          <a:off x="0" y="0"/>
-          <a:ext cx="0" cy="0"/>
-          <a:chOff x="0" y="0"/>
-          <a:chExt cx="0" cy="0"/>
-        </a:xfrm>
-      </p:grpSpPr>
+      <p:grpSpPr/>
       <p:sp>
         <p:nvSpPr>
           <p:cNvPr id="2" name="Rectangle 1"/>
@@ -5737,7 +5921,6 @@
           <a:lstStyle/>
           <a:p>
             <a:pPr algn="ctr"/>
-            <a:endParaRPr/>
           </a:p>
         </p:txBody>
       </p:sp>
@@ -5808,7 +5991,7 @@
               </a:defRPr>
             </a:pPr>
             <a:r>
-              <a:t>Dual-track funding for a 60-day supervised pilot.</a:t>
+              <a:t>US$387k pre-seed to a licensed, partner-held launch.</a:t>
             </a:r>
           </a:p>
         </p:txBody>
@@ -5853,7 +6036,6 @@
           <a:lstStyle/>
           <a:p>
             <a:pPr algn="ctr"/>
-            <a:endParaRPr/>
           </a:p>
         </p:txBody>
       </p:sp>
@@ -5866,7 +6048,7 @@
           <p:nvPr/>
         </p:nvPicPr>
         <p:blipFill>
-          <a:blip r:embed="rId3"/>
+          <a:blip r:embed="rId2"/>
           <a:stretch>
             <a:fillRect/>
           </a:stretch>
@@ -5904,14 +6086,14 @@
           <a:lstStyle/>
           <a:p>
             <a:pPr>
-              <a:defRPr sz="1200" b="1">
+              <a:defRPr b="1" sz="1200">
                 <a:solidFill>
                   <a:srgbClr val="2563EB"/>
                 </a:solidFill>
               </a:defRPr>
             </a:pPr>
             <a:r>
-              <a:t>TRACK A: LEAN BOOTSTRAP PILOT</a:t>
+              <a:t>STAGE 1: LEGAL PILOT (MONTHS 1–6)</a:t>
             </a:r>
           </a:p>
           <a:p>
@@ -5919,14 +6101,14 @@
               <a:spcBef>
                 <a:spcPts val="800"/>
               </a:spcBef>
-              <a:defRPr sz="2600" b="1">
+              <a:defRPr b="1" sz="2600">
                 <a:solidFill>
                   <a:srgbClr val="0F172A"/>
                 </a:solidFill>
               </a:defRPr>
             </a:pPr>
             <a:r>
-              <a:t>GHS 30,000  (~USD $2,500)</a:t>
+              <a:t>US$26k  (GHS 305k)</a:t>
             </a:r>
           </a:p>
           <a:p>
@@ -5941,7 +6123,7 @@
               </a:defRPr>
             </a:pPr>
             <a:r>
-              <a:t>✓  Entity formation (ORC) + GRA TIN + DPC registration</a:t>
+              <a:t>✓  Company, TIN, DPC registration, lawyer's custody opinion</a:t>
             </a:r>
           </a:p>
           <a:p>
@@ -5956,7 +6138,7 @@
               </a:defRPr>
             </a:pPr>
             <a:r>
-              <a:t>✓  Initial T+2 working capital float &amp; loss reserve (GHS 5k)</a:t>
+              <a:t>✓  Written aggregator approval; BoG sandbox or partner LOI</a:t>
             </a:r>
           </a:p>
           <a:p>
@@ -5971,7 +6153,7 @@
               </a:defRPr>
             </a:pPr>
             <a:r>
-              <a:t>✓  Lean CPU cloud hosting + SMS messaging (3 months)</a:t>
+              <a:t>✓  Founder stipends, part-time ops, lean hosting (AI on CPU)</a:t>
             </a:r>
           </a:p>
           <a:p>
@@ -5986,7 +6168,7 @@
               </a:defRPr>
             </a:pPr>
             <a:r>
-              <a:t>✓  60-day supervised pilot with 10–20 high-ticket vendors</a:t>
+              <a:t>✓  10–50 vendors; ~500 capped, disclosed live orders</a:t>
             </a:r>
           </a:p>
           <a:p>
@@ -6001,7 +6183,7 @@
               </a:defRPr>
             </a:pPr>
             <a:r>
-              <a:t>✓  Milestone: First 100+ live transactions on compliant rails</a:t>
+              <a:t>✓  Gate: buyer fee acceptance, order value, dispute rate</a:t>
             </a:r>
           </a:p>
         </p:txBody>
@@ -6046,7 +6228,6 @@
           <a:lstStyle/>
           <a:p>
             <a:pPr algn="ctr"/>
-            <a:endParaRPr/>
           </a:p>
         </p:txBody>
       </p:sp>
@@ -6073,14 +6254,14 @@
           <a:lstStyle/>
           <a:p>
             <a:pPr>
-              <a:defRPr sz="1200" b="1">
+              <a:defRPr b="1" sz="1200">
                 <a:solidFill>
                   <a:srgbClr val="1FC16B"/>
                 </a:solidFill>
               </a:defRPr>
             </a:pPr>
             <a:r>
-              <a:t>TRACK B: INSTITUTIONAL / ACCELERATED</a:t>
+              <a:t>STAGE 2: COMPLIANT LAUNCH (MONTHS 7–18)</a:t>
             </a:r>
           </a:p>
           <a:p>
@@ -6088,14 +6269,14 @@
               <a:spcBef>
                 <a:spcPts val="800"/>
               </a:spcBef>
-              <a:defRPr sz="2600" b="1">
+              <a:defRPr b="1" sz="2600">
                 <a:solidFill>
                   <a:srgbClr val="0F172A"/>
                 </a:solidFill>
               </a:defRPr>
             </a:pPr>
             <a:r>
-              <a:t>GHS 150,000  (~USD $12,500)</a:t>
+              <a:t>US$360k  (GHS 4.18M)</a:t>
             </a:r>
           </a:p>
           <a:p>
@@ -6110,7 +6291,7 @@
               </a:defRPr>
             </a:pPr>
             <a:r>
-              <a:t>✓  Specialist fintech legal counsel (BoG PFTSP opinion)</a:t>
+              <a:t>✓  BoG PFTSP licence + partner-bank trust account (P2)</a:t>
             </a:r>
           </a:p>
           <a:p>
@@ -6125,7 +6306,7 @@
               </a:defRPr>
             </a:pPr>
             <a:r>
-              <a:t>✓  Independent external penetration test &amp; security audit</a:t>
+              <a:t>✓  The five BoG management roles; ~12 staff</a:t>
             </a:r>
           </a:p>
           <a:p>
@@ -6140,7 +6321,7 @@
               </a:defRPr>
             </a:pPr>
             <a:r>
-              <a:t>✓  Multi-AZ PostgreSQL PITR + high-availability cloud infra</a:t>
+              <a:t>✓  External pentest, ISO 27001, full BoG policy set</a:t>
             </a:r>
           </a:p>
           <a:p>
@@ -6155,7 +6336,7 @@
               </a:defRPr>
             </a:pPr>
             <a:r>
-              <a:t>✓  Funded 2% GMV loss reserve &amp; T+2 working capital float</a:t>
+              <a:t>✓  Float (one day of order value) + partner reserve</a:t>
             </a:r>
           </a:p>
           <a:p>
@@ -6170,7 +6351,7 @@
               </a:defRPr>
             </a:pPr>
             <a:r>
-              <a:t>✓  Milestone: Total de-risking for P2 Bank trust onboarding</a:t>
+              <a:t>✓  Milestone: ~5,000 orders/month on compliant rails</a:t>
             </a:r>
           </a:p>
         </p:txBody>
@@ -6184,7 +6365,7 @@
 </file>
 
 <file path=ppt/slides/slide13.xml><?xml version="1.0" encoding="utf-8"?>
-<p:sld xmlns:a="http://schemas.openxmlformats.org/drawingml/2006/main" xmlns:r="http://schemas.openxmlformats.org/officeDocument/2006/relationships" xmlns:p="http://schemas.openxmlformats.org/presentationml/2006/main">
+<p:sld xmlns:a="http://schemas.openxmlformats.org/drawingml/2006/main" xmlns:p="http://schemas.openxmlformats.org/presentationml/2006/main" xmlns:r="http://schemas.openxmlformats.org/officeDocument/2006/relationships">
   <p:cSld>
     <p:spTree>
       <p:nvGrpSpPr>
@@ -6192,14 +6373,7 @@
         <p:cNvGrpSpPr/>
         <p:nvPr/>
       </p:nvGrpSpPr>
-      <p:grpSpPr>
-        <a:xfrm>
-          <a:off x="0" y="0"/>
-          <a:ext cx="0" cy="0"/>
-          <a:chOff x="0" y="0"/>
-          <a:chExt cx="0" cy="0"/>
-        </a:xfrm>
-      </p:grpSpPr>
+      <p:grpSpPr/>
       <p:sp>
         <p:nvSpPr>
           <p:cNvPr id="2" name="Rectangle 1"/>
@@ -6240,7 +6414,6 @@
           <a:lstStyle/>
           <a:p>
             <a:pPr algn="ctr"/>
-            <a:endParaRPr/>
           </a:p>
         </p:txBody>
       </p:sp>
@@ -6253,7 +6426,7 @@
           <p:nvPr/>
         </p:nvPicPr>
         <p:blipFill>
-          <a:blip r:embed="rId3"/>
+          <a:blip r:embed="rId2"/>
           <a:stretch>
             <a:fillRect/>
           </a:stretch>
@@ -6328,7 +6501,7 @@
 </file>
 
 <file path=ppt/slides/slide14.xml><?xml version="1.0" encoding="utf-8"?>
-<p:sld xmlns:a="http://schemas.openxmlformats.org/drawingml/2006/main" xmlns:r="http://schemas.openxmlformats.org/officeDocument/2006/relationships" xmlns:p="http://schemas.openxmlformats.org/presentationml/2006/main">
+<p:sld xmlns:a="http://schemas.openxmlformats.org/drawingml/2006/main" xmlns:p="http://schemas.openxmlformats.org/presentationml/2006/main" xmlns:r="http://schemas.openxmlformats.org/officeDocument/2006/relationships">
   <p:cSld>
     <p:spTree>
       <p:nvGrpSpPr>
@@ -6336,14 +6509,7 @@
         <p:cNvGrpSpPr/>
         <p:nvPr/>
       </p:nvGrpSpPr>
-      <p:grpSpPr>
-        <a:xfrm>
-          <a:off x="0" y="0"/>
-          <a:ext cx="0" cy="0"/>
-          <a:chOff x="0" y="0"/>
-          <a:chExt cx="0" cy="0"/>
-        </a:xfrm>
-      </p:grpSpPr>
+      <p:grpSpPr/>
       <p:sp>
         <p:nvSpPr>
           <p:cNvPr id="2" name="Rectangle 1"/>
@@ -6384,7 +6550,6 @@
           <a:lstStyle/>
           <a:p>
             <a:pPr algn="ctr"/>
-            <a:endParaRPr/>
           </a:p>
         </p:txBody>
       </p:sp>
@@ -6500,7 +6665,6 @@
           <a:lstStyle/>
           <a:p>
             <a:pPr algn="ctr"/>
-            <a:endParaRPr/>
           </a:p>
         </p:txBody>
       </p:sp>
@@ -6513,7 +6677,7 @@
           <p:nvPr/>
         </p:nvPicPr>
         <p:blipFill>
-          <a:blip r:embed="rId3"/>
+          <a:blip r:embed="rId2"/>
           <a:stretch>
             <a:fillRect/>
           </a:stretch>
@@ -6551,7 +6715,7 @@
           <a:lstStyle/>
           <a:p>
             <a:pPr>
-              <a:defRPr sz="2000" b="1">
+              <a:defRPr b="1" sz="2000">
                 <a:solidFill>
                   <a:srgbClr val="2563EB"/>
                 </a:solidFill>
@@ -6647,7 +6811,7 @@
 </file>
 
 <file path=ppt/slides/slide15.xml><?xml version="1.0" encoding="utf-8"?>
-<p:sld xmlns:a="http://schemas.openxmlformats.org/drawingml/2006/main" xmlns:r="http://schemas.openxmlformats.org/officeDocument/2006/relationships" xmlns:p="http://schemas.openxmlformats.org/presentationml/2006/main">
+<p:sld xmlns:a="http://schemas.openxmlformats.org/drawingml/2006/main" xmlns:p="http://schemas.openxmlformats.org/presentationml/2006/main" xmlns:r="http://schemas.openxmlformats.org/officeDocument/2006/relationships">
   <p:cSld>
     <p:spTree>
       <p:nvGrpSpPr>
@@ -6655,14 +6819,7 @@
         <p:cNvGrpSpPr/>
         <p:nvPr/>
       </p:nvGrpSpPr>
-      <p:grpSpPr>
-        <a:xfrm>
-          <a:off x="0" y="0"/>
-          <a:ext cx="0" cy="0"/>
-          <a:chOff x="0" y="0"/>
-          <a:chExt cx="0" cy="0"/>
-        </a:xfrm>
-      </p:grpSpPr>
+      <p:grpSpPr/>
       <p:sp>
         <p:nvSpPr>
           <p:cNvPr id="2" name="Rectangle 1"/>
@@ -6703,7 +6860,6 @@
           <a:lstStyle/>
           <a:p>
             <a:pPr algn="ctr"/>
-            <a:endParaRPr/>
           </a:p>
         </p:txBody>
       </p:sp>
@@ -6819,7 +6975,6 @@
           <a:lstStyle/>
           <a:p>
             <a:pPr algn="ctr"/>
-            <a:endParaRPr/>
           </a:p>
         </p:txBody>
       </p:sp>
@@ -6832,7 +6987,7 @@
           <p:nvPr/>
         </p:nvPicPr>
         <p:blipFill>
-          <a:blip r:embed="rId3"/>
+          <a:blip r:embed="rId2"/>
           <a:stretch>
             <a:fillRect/>
           </a:stretch>
@@ -6870,7 +7025,7 @@
           <a:lstStyle/>
           <a:p>
             <a:pPr>
-              <a:defRPr sz="2000" b="1">
+              <a:defRPr b="1" sz="2000">
                 <a:solidFill>
                   <a:srgbClr val="2563EB"/>
                 </a:solidFill>
@@ -6885,7 +7040,7 @@
               <a:spcBef>
                 <a:spcPts val="800"/>
               </a:spcBef>
-              <a:defRPr sz="1200" b="1">
+              <a:defRPr b="1" sz="1200">
                 <a:solidFill>
                   <a:srgbClr val="1FC16B"/>
                 </a:solidFill>
@@ -6943,7 +7098,7 @@
           <a:lstStyle/>
           <a:p>
             <a:pPr>
-              <a:defRPr sz="2000" b="1">
+              <a:defRPr b="1" sz="2000">
                 <a:solidFill>
                   <a:srgbClr val="2563EB"/>
                 </a:solidFill>
@@ -6958,7 +7113,7 @@
               <a:spcBef>
                 <a:spcPts val="800"/>
               </a:spcBef>
-              <a:defRPr sz="1200" b="1">
+              <a:defRPr b="1" sz="1200">
                 <a:solidFill>
                   <a:srgbClr val="1FC16B"/>
                 </a:solidFill>
@@ -7008,7 +7163,7 @@
           <a:lstStyle/>
           <a:p>
             <a:pPr>
-              <a:defRPr sz="2000" b="1">
+              <a:defRPr b="1" sz="2000">
                 <a:solidFill>
                   <a:srgbClr val="2563EB"/>
                 </a:solidFill>
@@ -7023,7 +7178,7 @@
               <a:spcBef>
                 <a:spcPts val="800"/>
               </a:spcBef>
-              <a:defRPr sz="1200" b="1">
+              <a:defRPr b="1" sz="1200">
                 <a:solidFill>
                   <a:srgbClr val="1FC16B"/>
                 </a:solidFill>
@@ -7059,7 +7214,7 @@
 </file>
 
 <file path=ppt/slides/slide16.xml><?xml version="1.0" encoding="utf-8"?>
-<p:sld xmlns:a="http://schemas.openxmlformats.org/drawingml/2006/main" xmlns:r="http://schemas.openxmlformats.org/officeDocument/2006/relationships" xmlns:p="http://schemas.openxmlformats.org/presentationml/2006/main">
+<p:sld xmlns:a="http://schemas.openxmlformats.org/drawingml/2006/main" xmlns:p="http://schemas.openxmlformats.org/presentationml/2006/main" xmlns:r="http://schemas.openxmlformats.org/officeDocument/2006/relationships">
   <p:cSld>
     <p:spTree>
       <p:nvGrpSpPr>
@@ -7067,14 +7222,7 @@
         <p:cNvGrpSpPr/>
         <p:nvPr/>
       </p:nvGrpSpPr>
-      <p:grpSpPr>
-        <a:xfrm>
-          <a:off x="0" y="0"/>
-          <a:ext cx="0" cy="0"/>
-          <a:chOff x="0" y="0"/>
-          <a:chExt cx="0" cy="0"/>
-        </a:xfrm>
-      </p:grpSpPr>
+      <p:grpSpPr/>
       <p:sp>
         <p:nvSpPr>
           <p:cNvPr id="2" name="Rectangle 1"/>
@@ -7115,7 +7263,6 @@
           <a:lstStyle/>
           <a:p>
             <a:pPr algn="ctr"/>
-            <a:endParaRPr/>
           </a:p>
         </p:txBody>
       </p:sp>
@@ -7231,7 +7378,6 @@
           <a:lstStyle/>
           <a:p>
             <a:pPr algn="ctr"/>
-            <a:endParaRPr/>
           </a:p>
         </p:txBody>
       </p:sp>
@@ -7244,7 +7390,7 @@
           <p:nvPr/>
         </p:nvPicPr>
         <p:blipFill>
-          <a:blip r:embed="rId3"/>
+          <a:blip r:embed="rId2"/>
           <a:stretch>
             <a:fillRect/>
           </a:stretch>
@@ -7282,7 +7428,7 @@
           <a:lstStyle/>
           <a:p>
             <a:pPr>
-              <a:defRPr sz="1400" b="1">
+              <a:defRPr b="1" sz="1400">
                 <a:solidFill>
                   <a:srgbClr val="DC2626"/>
                 </a:solidFill>
@@ -7329,7 +7475,7 @@
           <a:lstStyle/>
           <a:p>
             <a:pPr>
-              <a:defRPr sz="1400" b="1">
+              <a:defRPr b="1" sz="1400">
                 <a:solidFill>
                   <a:srgbClr val="DC2626"/>
                 </a:solidFill>
@@ -7376,7 +7522,7 @@
           <a:lstStyle/>
           <a:p>
             <a:pPr>
-              <a:defRPr sz="1400" b="1">
+              <a:defRPr b="1" sz="1400">
                 <a:solidFill>
                   <a:srgbClr val="DC2626"/>
                 </a:solidFill>
@@ -7423,7 +7569,7 @@
           <a:lstStyle/>
           <a:p>
             <a:pPr>
-              <a:defRPr sz="1400" b="1">
+              <a:defRPr b="1" sz="1400">
                 <a:solidFill>
                   <a:srgbClr val="DC2626"/>
                 </a:solidFill>
@@ -7470,7 +7616,7 @@
           <a:lstStyle/>
           <a:p>
             <a:pPr>
-              <a:defRPr sz="1400" b="1">
+              <a:defRPr b="1" sz="1400">
                 <a:solidFill>
                   <a:srgbClr val="DC2626"/>
                 </a:solidFill>
@@ -7517,7 +7663,7 @@
           <a:lstStyle/>
           <a:p>
             <a:pPr>
-              <a:defRPr sz="1400" b="1">
+              <a:defRPr b="1" sz="1400">
                 <a:solidFill>
                   <a:srgbClr val="DC2626"/>
                 </a:solidFill>
@@ -7536,7 +7682,7 @@
               </a:defRPr>
             </a:pPr>
             <a:r>
-              <a:t>Mitigation: Written adjudication policy, loss reserve funded at 2% GMV, appeal path, and ToS liability caps.</a:t>
+              <a:t>Mitigation: Written adjudication policy, ring-fenced loss reserve plus 0.3% of order value per order, appeal path, and ToS liability caps.</a:t>
             </a:r>
           </a:p>
         </p:txBody>
@@ -7550,7 +7696,7 @@
 </file>
 
 <file path=ppt/slides/slide17.xml><?xml version="1.0" encoding="utf-8"?>
-<p:sld xmlns:a="http://schemas.openxmlformats.org/drawingml/2006/main" xmlns:r="http://schemas.openxmlformats.org/officeDocument/2006/relationships" xmlns:p="http://schemas.openxmlformats.org/presentationml/2006/main">
+<p:sld xmlns:a="http://schemas.openxmlformats.org/drawingml/2006/main" xmlns:p="http://schemas.openxmlformats.org/presentationml/2006/main" xmlns:r="http://schemas.openxmlformats.org/officeDocument/2006/relationships">
   <p:cSld>
     <p:spTree>
       <p:nvGrpSpPr>
@@ -7558,14 +7704,7 @@
         <p:cNvGrpSpPr/>
         <p:nvPr/>
       </p:nvGrpSpPr>
-      <p:grpSpPr>
-        <a:xfrm>
-          <a:off x="0" y="0"/>
-          <a:ext cx="0" cy="0"/>
-          <a:chOff x="0" y="0"/>
-          <a:chExt cx="0" cy="0"/>
-        </a:xfrm>
-      </p:grpSpPr>
+      <p:grpSpPr/>
       <p:sp>
         <p:nvSpPr>
           <p:cNvPr id="2" name="Rectangle 1"/>
@@ -7606,7 +7745,6 @@
           <a:lstStyle/>
           <a:p>
             <a:pPr algn="ctr"/>
-            <a:endParaRPr/>
           </a:p>
         </p:txBody>
       </p:sp>
@@ -7722,7 +7860,6 @@
           <a:lstStyle/>
           <a:p>
             <a:pPr algn="ctr"/>
-            <a:endParaRPr/>
           </a:p>
         </p:txBody>
       </p:sp>
@@ -7735,7 +7872,7 @@
           <p:nvPr/>
         </p:nvPicPr>
         <p:blipFill>
-          <a:blip r:embed="rId3"/>
+          <a:blip r:embed="rId2"/>
           <a:stretch>
             <a:fillRect/>
           </a:stretch>
@@ -7773,7 +7910,7 @@
           <a:lstStyle/>
           <a:p>
             <a:pPr>
-              <a:defRPr sz="2000" b="1">
+              <a:defRPr b="1" sz="2000">
                 <a:solidFill>
                   <a:srgbClr val="2563EB"/>
                 </a:solidFill>
@@ -7788,7 +7925,7 @@
               <a:spcBef>
                 <a:spcPts val="800"/>
               </a:spcBef>
-              <a:defRPr sz="1200" b="1">
+              <a:defRPr b="1" sz="1200">
                 <a:solidFill>
                   <a:srgbClr val="1FC16B"/>
                 </a:solidFill>
@@ -7838,7 +7975,7 @@
           <a:lstStyle/>
           <a:p>
             <a:pPr>
-              <a:defRPr sz="2000" b="1">
+              <a:defRPr b="1" sz="2000">
                 <a:solidFill>
                   <a:srgbClr val="2563EB"/>
                 </a:solidFill>
@@ -7853,7 +7990,7 @@
               <a:spcBef>
                 <a:spcPts val="800"/>
               </a:spcBef>
-              <a:defRPr sz="1200" b="1">
+              <a:defRPr b="1" sz="1200">
                 <a:solidFill>
                   <a:srgbClr val="1FC16B"/>
                 </a:solidFill>
@@ -7903,7 +8040,7 @@
           <a:lstStyle/>
           <a:p>
             <a:pPr>
-              <a:defRPr sz="2000" b="1">
+              <a:defRPr b="1" sz="2000">
                 <a:solidFill>
                   <a:srgbClr val="2563EB"/>
                 </a:solidFill>
@@ -7918,7 +8055,7 @@
               <a:spcBef>
                 <a:spcPts val="800"/>
               </a:spcBef>
-              <a:defRPr sz="1200" b="1">
+              <a:defRPr b="1" sz="1200">
                 <a:solidFill>
                   <a:srgbClr val="1FC16B"/>
                 </a:solidFill>
@@ -7954,7 +8091,7 @@
 </file>
 
 <file path=ppt/slides/slide18.xml><?xml version="1.0" encoding="utf-8"?>
-<p:sld xmlns:a="http://schemas.openxmlformats.org/drawingml/2006/main" xmlns:r="http://schemas.openxmlformats.org/officeDocument/2006/relationships" xmlns:p="http://schemas.openxmlformats.org/presentationml/2006/main">
+<p:sld xmlns:a="http://schemas.openxmlformats.org/drawingml/2006/main" xmlns:p="http://schemas.openxmlformats.org/presentationml/2006/main" xmlns:r="http://schemas.openxmlformats.org/officeDocument/2006/relationships">
   <p:cSld>
     <p:spTree>
       <p:nvGrpSpPr>
@@ -7962,14 +8099,7 @@
         <p:cNvGrpSpPr/>
         <p:nvPr/>
       </p:nvGrpSpPr>
-      <p:grpSpPr>
-        <a:xfrm>
-          <a:off x="0" y="0"/>
-          <a:ext cx="0" cy="0"/>
-          <a:chOff x="0" y="0"/>
-          <a:chExt cx="0" cy="0"/>
-        </a:xfrm>
-      </p:grpSpPr>
+      <p:grpSpPr/>
       <p:sp>
         <p:nvSpPr>
           <p:cNvPr id="2" name="Rectangle 1"/>
@@ -8010,7 +8140,6 @@
           <a:lstStyle/>
           <a:p>
             <a:pPr algn="ctr"/>
-            <a:endParaRPr/>
           </a:p>
         </p:txBody>
       </p:sp>
@@ -8126,7 +8255,6 @@
           <a:lstStyle/>
           <a:p>
             <a:pPr algn="ctr"/>
-            <a:endParaRPr/>
           </a:p>
         </p:txBody>
       </p:sp>
@@ -8139,7 +8267,7 @@
           <p:nvPr/>
         </p:nvPicPr>
         <p:blipFill>
-          <a:blip r:embed="rId3"/>
+          <a:blip r:embed="rId2"/>
           <a:stretch>
             <a:fillRect/>
           </a:stretch>
@@ -8177,7 +8305,7 @@
           <a:lstStyle/>
           <a:p>
             <a:pPr>
-              <a:defRPr sz="1500" b="1">
+              <a:defRPr b="1" sz="1500">
                 <a:solidFill>
                   <a:srgbClr val="2563EB"/>
                 </a:solidFill>
@@ -8227,7 +8355,7 @@
           <a:lstStyle/>
           <a:p>
             <a:pPr>
-              <a:defRPr sz="1500" b="1">
+              <a:defRPr b="1" sz="1500">
                 <a:solidFill>
                   <a:srgbClr val="2563EB"/>
                 </a:solidFill>
@@ -8277,7 +8405,7 @@
           <a:lstStyle/>
           <a:p>
             <a:pPr>
-              <a:defRPr sz="1500" b="1">
+              <a:defRPr b="1" sz="1500">
                 <a:solidFill>
                   <a:srgbClr val="2563EB"/>
                 </a:solidFill>
@@ -8327,7 +8455,7 @@
           <a:lstStyle/>
           <a:p>
             <a:pPr>
-              <a:defRPr sz="1500" b="1">
+              <a:defRPr b="1" sz="1500">
                 <a:solidFill>
                   <a:srgbClr val="2563EB"/>
                 </a:solidFill>
@@ -8363,7 +8491,7 @@
 </file>
 
 <file path=ppt/slides/slide2.xml><?xml version="1.0" encoding="utf-8"?>
-<p:sld xmlns:a="http://schemas.openxmlformats.org/drawingml/2006/main" xmlns:r="http://schemas.openxmlformats.org/officeDocument/2006/relationships" xmlns:p="http://schemas.openxmlformats.org/presentationml/2006/main">
+<p:sld xmlns:a="http://schemas.openxmlformats.org/drawingml/2006/main" xmlns:p="http://schemas.openxmlformats.org/presentationml/2006/main" xmlns:r="http://schemas.openxmlformats.org/officeDocument/2006/relationships">
   <p:cSld>
     <p:spTree>
       <p:nvGrpSpPr>
@@ -8371,14 +8499,7 @@
         <p:cNvGrpSpPr/>
         <p:nvPr/>
       </p:nvGrpSpPr>
-      <p:grpSpPr>
-        <a:xfrm>
-          <a:off x="0" y="0"/>
-          <a:ext cx="0" cy="0"/>
-          <a:chOff x="0" y="0"/>
-          <a:chExt cx="0" cy="0"/>
-        </a:xfrm>
-      </p:grpSpPr>
+      <p:grpSpPr/>
       <p:sp>
         <p:nvSpPr>
           <p:cNvPr id="2" name="Rectangle 1"/>
@@ -8419,7 +8540,6 @@
           <a:lstStyle/>
           <a:p>
             <a:pPr algn="ctr"/>
-            <a:endParaRPr/>
           </a:p>
         </p:txBody>
       </p:sp>
@@ -8535,7 +8655,6 @@
           <a:lstStyle/>
           <a:p>
             <a:pPr algn="ctr"/>
-            <a:endParaRPr/>
           </a:p>
         </p:txBody>
       </p:sp>
@@ -8548,7 +8667,7 @@
           <p:nvPr/>
         </p:nvPicPr>
         <p:blipFill>
-          <a:blip r:embed="rId3"/>
+          <a:blip r:embed="rId2"/>
           <a:stretch>
             <a:fillRect/>
           </a:stretch>
@@ -8586,7 +8705,7 @@
           <a:lstStyle/>
           <a:p>
             <a:pPr>
-              <a:defRPr sz="1800" b="1">
+              <a:defRPr b="1" sz="1800">
                 <a:solidFill>
                   <a:srgbClr val="0F172A"/>
                 </a:solidFill>
@@ -8639,7 +8758,7 @@
               <a:spcBef>
                 <a:spcPts val="3000"/>
               </a:spcBef>
-              <a:defRPr sz="1600" b="1">
+              <a:defRPr b="1" sz="1600">
                 <a:solidFill>
                   <a:srgbClr val="1FC16B"/>
                 </a:solidFill>
@@ -8691,7 +8810,6 @@
           <a:lstStyle/>
           <a:p>
             <a:pPr algn="ctr"/>
-            <a:endParaRPr/>
           </a:p>
         </p:txBody>
       </p:sp>
@@ -8718,7 +8836,7 @@
           <a:lstStyle/>
           <a:p>
             <a:pPr>
-              <a:defRPr sz="1800" b="1">
+              <a:defRPr b="1" sz="1800">
                 <a:solidFill>
                   <a:srgbClr val="DC2626"/>
                 </a:solidFill>
@@ -8768,7 +8886,7 @@
           <a:lstStyle/>
           <a:p>
             <a:pPr>
-              <a:defRPr sz="1800" b="1">
+              <a:defRPr b="1" sz="1800">
                 <a:solidFill>
                   <a:srgbClr val="2563EB"/>
                 </a:solidFill>
@@ -8804,7 +8922,7 @@
 </file>
 
 <file path=ppt/slides/slide3.xml><?xml version="1.0" encoding="utf-8"?>
-<p:sld xmlns:a="http://schemas.openxmlformats.org/drawingml/2006/main" xmlns:r="http://schemas.openxmlformats.org/officeDocument/2006/relationships" xmlns:p="http://schemas.openxmlformats.org/presentationml/2006/main">
+<p:sld xmlns:a="http://schemas.openxmlformats.org/drawingml/2006/main" xmlns:p="http://schemas.openxmlformats.org/presentationml/2006/main" xmlns:r="http://schemas.openxmlformats.org/officeDocument/2006/relationships">
   <p:cSld>
     <p:spTree>
       <p:nvGrpSpPr>
@@ -8812,14 +8930,7 @@
         <p:cNvGrpSpPr/>
         <p:nvPr/>
       </p:nvGrpSpPr>
-      <p:grpSpPr>
-        <a:xfrm>
-          <a:off x="0" y="0"/>
-          <a:ext cx="0" cy="0"/>
-          <a:chOff x="0" y="0"/>
-          <a:chExt cx="0" cy="0"/>
-        </a:xfrm>
-      </p:grpSpPr>
+      <p:grpSpPr/>
       <p:sp>
         <p:nvSpPr>
           <p:cNvPr id="2" name="Rectangle 1"/>
@@ -8860,7 +8971,6 @@
           <a:lstStyle/>
           <a:p>
             <a:pPr algn="ctr"/>
-            <a:endParaRPr/>
           </a:p>
         </p:txBody>
       </p:sp>
@@ -8976,7 +9086,6 @@
           <a:lstStyle/>
           <a:p>
             <a:pPr algn="ctr"/>
-            <a:endParaRPr/>
           </a:p>
         </p:txBody>
       </p:sp>
@@ -8989,7 +9098,7 @@
           <p:nvPr/>
         </p:nvPicPr>
         <p:blipFill>
-          <a:blip r:embed="rId3"/>
+          <a:blip r:embed="rId2"/>
           <a:stretch>
             <a:fillRect/>
           </a:stretch>
@@ -9062,7 +9171,7 @@
           <a:lstStyle/>
           <a:p>
             <a:pPr>
-              <a:defRPr sz="2000" b="1">
+              <a:defRPr b="1" sz="2000">
                 <a:solidFill>
                   <a:srgbClr val="0F172A"/>
                 </a:solidFill>
@@ -9147,7 +9256,7 @@
           <a:lstStyle/>
           <a:p>
             <a:pPr>
-              <a:defRPr sz="2000" b="1">
+              <a:defRPr b="1" sz="2000">
                 <a:solidFill>
                   <a:srgbClr val="0F172A"/>
                 </a:solidFill>
@@ -9232,7 +9341,7 @@
           <a:lstStyle/>
           <a:p>
             <a:pPr>
-              <a:defRPr sz="2000" b="1">
+              <a:defRPr b="1" sz="2000">
                 <a:solidFill>
                   <a:srgbClr val="0F172A"/>
                 </a:solidFill>
@@ -9268,7 +9377,7 @@
 </file>
 
 <file path=ppt/slides/slide4.xml><?xml version="1.0" encoding="utf-8"?>
-<p:sld xmlns:a="http://schemas.openxmlformats.org/drawingml/2006/main" xmlns:r="http://schemas.openxmlformats.org/officeDocument/2006/relationships" xmlns:p="http://schemas.openxmlformats.org/presentationml/2006/main">
+<p:sld xmlns:a="http://schemas.openxmlformats.org/drawingml/2006/main" xmlns:p="http://schemas.openxmlformats.org/presentationml/2006/main" xmlns:r="http://schemas.openxmlformats.org/officeDocument/2006/relationships">
   <p:cSld>
     <p:spTree>
       <p:nvGrpSpPr>
@@ -9276,14 +9385,7 @@
         <p:cNvGrpSpPr/>
         <p:nvPr/>
       </p:nvGrpSpPr>
-      <p:grpSpPr>
-        <a:xfrm>
-          <a:off x="0" y="0"/>
-          <a:ext cx="0" cy="0"/>
-          <a:chOff x="0" y="0"/>
-          <a:chExt cx="0" cy="0"/>
-        </a:xfrm>
-      </p:grpSpPr>
+      <p:grpSpPr/>
       <p:sp>
         <p:nvSpPr>
           <p:cNvPr id="2" name="Rectangle 1"/>
@@ -9324,7 +9426,6 @@
           <a:lstStyle/>
           <a:p>
             <a:pPr algn="ctr"/>
-            <a:endParaRPr/>
           </a:p>
         </p:txBody>
       </p:sp>
@@ -9440,7 +9541,6 @@
           <a:lstStyle/>
           <a:p>
             <a:pPr algn="ctr"/>
-            <a:endParaRPr/>
           </a:p>
         </p:txBody>
       </p:sp>
@@ -9453,7 +9553,7 @@
           <p:nvPr/>
         </p:nvPicPr>
         <p:blipFill>
-          <a:blip r:embed="rId3"/>
+          <a:blip r:embed="rId2"/>
           <a:stretch>
             <a:fillRect/>
           </a:stretch>
@@ -9491,7 +9591,7 @@
           <a:lstStyle/>
           <a:p>
             <a:pPr>
-              <a:defRPr sz="1400" b="1">
+              <a:defRPr b="1" sz="1400">
                 <a:solidFill>
                   <a:srgbClr val="1FC16B"/>
                 </a:solidFill>
@@ -9526,7 +9626,7 @@
           <a:lstStyle/>
           <a:p>
             <a:pPr>
-              <a:defRPr sz="1800" b="1">
+              <a:defRPr b="1" sz="1800">
                 <a:solidFill>
                   <a:srgbClr val="0F172A"/>
                 </a:solidFill>
@@ -9576,7 +9676,7 @@
           <a:lstStyle/>
           <a:p>
             <a:pPr>
-              <a:defRPr sz="1400" b="1">
+              <a:defRPr b="1" sz="1400">
                 <a:solidFill>
                   <a:srgbClr val="1FC16B"/>
                 </a:solidFill>
@@ -9611,7 +9711,7 @@
           <a:lstStyle/>
           <a:p>
             <a:pPr>
-              <a:defRPr sz="1800" b="1">
+              <a:defRPr b="1" sz="1800">
                 <a:solidFill>
                   <a:srgbClr val="0F172A"/>
                 </a:solidFill>
@@ -9661,7 +9761,7 @@
           <a:lstStyle/>
           <a:p>
             <a:pPr>
-              <a:defRPr sz="1400" b="1">
+              <a:defRPr b="1" sz="1400">
                 <a:solidFill>
                   <a:srgbClr val="1FC16B"/>
                 </a:solidFill>
@@ -9696,7 +9796,7 @@
           <a:lstStyle/>
           <a:p>
             <a:pPr>
-              <a:defRPr sz="1800" b="1">
+              <a:defRPr b="1" sz="1800">
                 <a:solidFill>
                   <a:srgbClr val="0F172A"/>
                 </a:solidFill>
@@ -9746,7 +9846,7 @@
           <a:lstStyle/>
           <a:p>
             <a:pPr>
-              <a:defRPr sz="1400" b="1">
+              <a:defRPr b="1" sz="1400">
                 <a:solidFill>
                   <a:srgbClr val="1FC16B"/>
                 </a:solidFill>
@@ -9781,7 +9881,7 @@
           <a:lstStyle/>
           <a:p>
             <a:pPr>
-              <a:defRPr sz="1800" b="1">
+              <a:defRPr b="1" sz="1800">
                 <a:solidFill>
                   <a:srgbClr val="0F172A"/>
                 </a:solidFill>
@@ -9803,7 +9903,7 @@
               </a:defRPr>
             </a:pPr>
             <a:r>
-              <a:t>Buyer confirms delivery in app; vendor is paid automatically, less 2.0% commission.</a:t>
+              <a:t>Buyer confirms delivery in app; vendor is paid automatically, less 2.5% commission.</a:t>
             </a:r>
           </a:p>
         </p:txBody>
@@ -9817,7 +9917,7 @@
 </file>
 
 <file path=ppt/slides/slide5.xml><?xml version="1.0" encoding="utf-8"?>
-<p:sld xmlns:a="http://schemas.openxmlformats.org/drawingml/2006/main" xmlns:r="http://schemas.openxmlformats.org/officeDocument/2006/relationships" xmlns:p="http://schemas.openxmlformats.org/presentationml/2006/main">
+<p:sld xmlns:a="http://schemas.openxmlformats.org/drawingml/2006/main" xmlns:p="http://schemas.openxmlformats.org/presentationml/2006/main" xmlns:r="http://schemas.openxmlformats.org/officeDocument/2006/relationships">
   <p:cSld>
     <p:spTree>
       <p:nvGrpSpPr>
@@ -9825,14 +9925,7 @@
         <p:cNvGrpSpPr/>
         <p:nvPr/>
       </p:nvGrpSpPr>
-      <p:grpSpPr>
-        <a:xfrm>
-          <a:off x="0" y="0"/>
-          <a:ext cx="0" cy="0"/>
-          <a:chOff x="0" y="0"/>
-          <a:chExt cx="0" cy="0"/>
-        </a:xfrm>
-      </p:grpSpPr>
+      <p:grpSpPr/>
       <p:sp>
         <p:nvSpPr>
           <p:cNvPr id="2" name="Rectangle 1"/>
@@ -9873,7 +9966,6 @@
           <a:lstStyle/>
           <a:p>
             <a:pPr algn="ctr"/>
-            <a:endParaRPr/>
           </a:p>
         </p:txBody>
       </p:sp>
@@ -9989,7 +10081,6 @@
           <a:lstStyle/>
           <a:p>
             <a:pPr algn="ctr"/>
-            <a:endParaRPr/>
           </a:p>
         </p:txBody>
       </p:sp>
@@ -10002,7 +10093,7 @@
           <p:nvPr/>
         </p:nvPicPr>
         <p:blipFill>
-          <a:blip r:embed="rId3"/>
+          <a:blip r:embed="rId2"/>
           <a:stretch>
             <a:fillRect/>
           </a:stretch>
@@ -10040,7 +10131,7 @@
           <a:lstStyle/>
           <a:p>
             <a:pPr>
-              <a:defRPr sz="2000" b="1">
+              <a:defRPr b="1" sz="2000">
                 <a:solidFill>
                   <a:srgbClr val="2563EB"/>
                 </a:solidFill>
@@ -10193,7 +10284,7 @@
           </a:p>
           <a:p>
             <a:pPr>
-              <a:defRPr sz="1600" b="1">
+              <a:defRPr b="1" sz="1600">
                 <a:solidFill>
                   <a:srgbClr val="0F172A"/>
                 </a:solidFill>
@@ -10226,9 +10317,7 @@
             <a:spAutoFit/>
           </a:bodyPr>
           <a:lstStyle/>
-          <a:p>
-            <a:endParaRPr/>
-          </a:p>
+          <a:p/>
           <a:p>
             <a:pPr>
               <a:spcBef>
@@ -10300,7 +10389,7 @@
 </file>
 
 <file path=ppt/slides/slide6.xml><?xml version="1.0" encoding="utf-8"?>
-<p:sld xmlns:a="http://schemas.openxmlformats.org/drawingml/2006/main" xmlns:r="http://schemas.openxmlformats.org/officeDocument/2006/relationships" xmlns:p="http://schemas.openxmlformats.org/presentationml/2006/main">
+<p:sld xmlns:a="http://schemas.openxmlformats.org/drawingml/2006/main" xmlns:p="http://schemas.openxmlformats.org/presentationml/2006/main" xmlns:r="http://schemas.openxmlformats.org/officeDocument/2006/relationships">
   <p:cSld>
     <p:spTree>
       <p:nvGrpSpPr>
@@ -10308,14 +10397,7 @@
         <p:cNvGrpSpPr/>
         <p:nvPr/>
       </p:nvGrpSpPr>
-      <p:grpSpPr>
-        <a:xfrm>
-          <a:off x="0" y="0"/>
-          <a:ext cx="0" cy="0"/>
-          <a:chOff x="0" y="0"/>
-          <a:chExt cx="0" cy="0"/>
-        </a:xfrm>
-      </p:grpSpPr>
+      <p:grpSpPr/>
       <p:sp>
         <p:nvSpPr>
           <p:cNvPr id="2" name="Rectangle 1"/>
@@ -10356,7 +10438,6 @@
           <a:lstStyle/>
           <a:p>
             <a:pPr algn="ctr"/>
-            <a:endParaRPr/>
           </a:p>
         </p:txBody>
       </p:sp>
@@ -10472,7 +10553,6 @@
           <a:lstStyle/>
           <a:p>
             <a:pPr algn="ctr"/>
-            <a:endParaRPr/>
           </a:p>
         </p:txBody>
       </p:sp>
@@ -10485,7 +10565,7 @@
           <p:nvPr/>
         </p:nvPicPr>
         <p:blipFill>
-          <a:blip r:embed="rId3"/>
+          <a:blip r:embed="rId2"/>
           <a:stretch>
             <a:fillRect/>
           </a:stretch>
@@ -10523,7 +10603,7 @@
           <a:lstStyle/>
           <a:p>
             <a:pPr>
-              <a:defRPr sz="1600" b="1">
+              <a:defRPr b="1" sz="1600">
                 <a:solidFill>
                   <a:srgbClr val="1FC16B"/>
                 </a:solidFill>
@@ -10573,7 +10653,7 @@
           <a:lstStyle/>
           <a:p>
             <a:pPr>
-              <a:defRPr sz="1800" b="1">
+              <a:defRPr b="1" sz="1800">
                 <a:solidFill>
                   <a:srgbClr val="DC2626"/>
                 </a:solidFill>
@@ -10668,7 +10748,7 @@
           <a:lstStyle/>
           <a:p>
             <a:pPr>
-              <a:defRPr sz="1800" b="1">
+              <a:defRPr b="1" sz="1800">
                 <a:solidFill>
                   <a:srgbClr val="2563EB"/>
                 </a:solidFill>
@@ -10749,7 +10829,7 @@
 </file>
 
 <file path=ppt/slides/slide7.xml><?xml version="1.0" encoding="utf-8"?>
-<p:sld xmlns:a="http://schemas.openxmlformats.org/drawingml/2006/main" xmlns:r="http://schemas.openxmlformats.org/officeDocument/2006/relationships" xmlns:p="http://schemas.openxmlformats.org/presentationml/2006/main">
+<p:sld xmlns:a="http://schemas.openxmlformats.org/drawingml/2006/main" xmlns:p="http://schemas.openxmlformats.org/presentationml/2006/main" xmlns:r="http://schemas.openxmlformats.org/officeDocument/2006/relationships">
   <p:cSld>
     <p:spTree>
       <p:nvGrpSpPr>
@@ -10757,14 +10837,7 @@
         <p:cNvGrpSpPr/>
         <p:nvPr/>
       </p:nvGrpSpPr>
-      <p:grpSpPr>
-        <a:xfrm>
-          <a:off x="0" y="0"/>
-          <a:ext cx="0" cy="0"/>
-          <a:chOff x="0" y="0"/>
-          <a:chExt cx="0" cy="0"/>
-        </a:xfrm>
-      </p:grpSpPr>
+      <p:grpSpPr/>
       <p:sp>
         <p:nvSpPr>
           <p:cNvPr id="2" name="Rectangle 1"/>
@@ -10805,7 +10878,6 @@
           <a:lstStyle/>
           <a:p>
             <a:pPr algn="ctr"/>
-            <a:endParaRPr/>
           </a:p>
         </p:txBody>
       </p:sp>
@@ -10921,7 +10993,6 @@
           <a:lstStyle/>
           <a:p>
             <a:pPr algn="ctr"/>
-            <a:endParaRPr/>
           </a:p>
         </p:txBody>
       </p:sp>
@@ -10934,7 +11005,7 @@
           <p:nvPr/>
         </p:nvPicPr>
         <p:blipFill>
-          <a:blip r:embed="rId3"/>
+          <a:blip r:embed="rId2"/>
           <a:stretch>
             <a:fillRect/>
           </a:stretch>
@@ -10972,7 +11043,7 @@
           <a:lstStyle/>
           <a:p>
             <a:pPr>
-              <a:defRPr sz="1600" b="1">
+              <a:defRPr b="1" sz="1600">
                 <a:solidFill>
                   <a:srgbClr val="0F172A"/>
                 </a:solidFill>
@@ -11036,7 +11107,6 @@
           <a:lstStyle/>
           <a:p>
             <a:pPr algn="ctr"/>
-            <a:endParaRPr/>
           </a:p>
         </p:txBody>
       </p:sp>
@@ -11063,7 +11133,7 @@
           <a:lstStyle/>
           <a:p>
             <a:pPr>
-              <a:defRPr sz="1600" b="1">
+              <a:defRPr b="1" sz="1600">
                 <a:solidFill>
                   <a:srgbClr val="0F172A"/>
                 </a:solidFill>
@@ -11127,7 +11197,6 @@
           <a:lstStyle/>
           <a:p>
             <a:pPr algn="ctr"/>
-            <a:endParaRPr/>
           </a:p>
         </p:txBody>
       </p:sp>
@@ -11154,7 +11223,7 @@
           <a:lstStyle/>
           <a:p>
             <a:pPr>
-              <a:defRPr sz="1600" b="1">
+              <a:defRPr b="1" sz="1600">
                 <a:solidFill>
                   <a:srgbClr val="2563EB"/>
                 </a:solidFill>
@@ -11218,7 +11287,6 @@
           <a:lstStyle/>
           <a:p>
             <a:pPr algn="ctr"/>
-            <a:endParaRPr/>
           </a:p>
         </p:txBody>
       </p:sp>
@@ -11245,7 +11313,7 @@
           <a:lstStyle/>
           <a:p>
             <a:pPr>
-              <a:defRPr sz="1600" b="1">
+              <a:defRPr b="1" sz="1600">
                 <a:solidFill>
                   <a:srgbClr val="0F172A"/>
                 </a:solidFill>
@@ -11292,7 +11360,7 @@
           <a:lstStyle/>
           <a:p>
             <a:pPr>
-              <a:defRPr sz="1300" b="1">
+              <a:defRPr b="1" sz="1300">
                 <a:solidFill>
                   <a:srgbClr val="1FC16B"/>
                 </a:solidFill>
@@ -11313,7 +11381,7 @@
 </file>
 
 <file path=ppt/slides/slide8.xml><?xml version="1.0" encoding="utf-8"?>
-<p:sld xmlns:a="http://schemas.openxmlformats.org/drawingml/2006/main" xmlns:r="http://schemas.openxmlformats.org/officeDocument/2006/relationships" xmlns:p="http://schemas.openxmlformats.org/presentationml/2006/main">
+<p:sld xmlns:a="http://schemas.openxmlformats.org/drawingml/2006/main" xmlns:p="http://schemas.openxmlformats.org/presentationml/2006/main" xmlns:r="http://schemas.openxmlformats.org/officeDocument/2006/relationships">
   <p:cSld>
     <p:spTree>
       <p:nvGrpSpPr>
@@ -11321,14 +11389,7 @@
         <p:cNvGrpSpPr/>
         <p:nvPr/>
       </p:nvGrpSpPr>
-      <p:grpSpPr>
-        <a:xfrm>
-          <a:off x="0" y="0"/>
-          <a:ext cx="0" cy="0"/>
-          <a:chOff x="0" y="0"/>
-          <a:chExt cx="0" cy="0"/>
-        </a:xfrm>
-      </p:grpSpPr>
+      <p:grpSpPr/>
       <p:sp>
         <p:nvSpPr>
           <p:cNvPr id="2" name="Rectangle 1"/>
@@ -11369,7 +11430,6 @@
           <a:lstStyle/>
           <a:p>
             <a:pPr algn="ctr"/>
-            <a:endParaRPr/>
           </a:p>
         </p:txBody>
       </p:sp>
@@ -11485,7 +11545,6 @@
           <a:lstStyle/>
           <a:p>
             <a:pPr algn="ctr"/>
-            <a:endParaRPr/>
           </a:p>
         </p:txBody>
       </p:sp>
@@ -11498,7 +11557,7 @@
           <p:nvPr/>
         </p:nvPicPr>
         <p:blipFill>
-          <a:blip r:embed="rId3"/>
+          <a:blip r:embed="rId2"/>
           <a:stretch>
             <a:fillRect/>
           </a:stretch>
@@ -11571,7 +11630,7 @@
           <a:lstStyle/>
           <a:p>
             <a:pPr>
-              <a:defRPr sz="2000" b="1">
+              <a:defRPr b="1" sz="2000">
                 <a:solidFill>
                   <a:srgbClr val="0F172A"/>
                 </a:solidFill>
@@ -11656,7 +11715,7 @@
           <a:lstStyle/>
           <a:p>
             <a:pPr>
-              <a:defRPr sz="2000" b="1">
+              <a:defRPr b="1" sz="2000">
                 <a:solidFill>
                   <a:srgbClr val="0F172A"/>
                 </a:solidFill>
@@ -11741,7 +11800,7 @@
           <a:lstStyle/>
           <a:p>
             <a:pPr>
-              <a:defRPr sz="2000" b="1">
+              <a:defRPr b="1" sz="2000">
                 <a:solidFill>
                   <a:srgbClr val="0F172A"/>
                 </a:solidFill>
@@ -11791,7 +11850,7 @@
           <a:lstStyle/>
           <a:p>
             <a:pPr>
-              <a:defRPr sz="1300" b="1">
+              <a:defRPr b="1" sz="1300">
                 <a:solidFill>
                   <a:srgbClr val="64748B"/>
                 </a:solidFill>
@@ -11812,7 +11871,7 @@
 </file>
 
 <file path=ppt/slides/slide9.xml><?xml version="1.0" encoding="utf-8"?>
-<p:sld xmlns:a="http://schemas.openxmlformats.org/drawingml/2006/main" xmlns:r="http://schemas.openxmlformats.org/officeDocument/2006/relationships" xmlns:p="http://schemas.openxmlformats.org/presentationml/2006/main">
+<p:sld xmlns:a="http://schemas.openxmlformats.org/drawingml/2006/main" xmlns:p="http://schemas.openxmlformats.org/presentationml/2006/main" xmlns:r="http://schemas.openxmlformats.org/officeDocument/2006/relationships">
   <p:cSld>
     <p:spTree>
       <p:nvGrpSpPr>
@@ -11820,14 +11879,7 @@
         <p:cNvGrpSpPr/>
         <p:nvPr/>
       </p:nvGrpSpPr>
-      <p:grpSpPr>
-        <a:xfrm>
-          <a:off x="0" y="0"/>
-          <a:ext cx="0" cy="0"/>
-          <a:chOff x="0" y="0"/>
-          <a:chExt cx="0" cy="0"/>
-        </a:xfrm>
-      </p:grpSpPr>
+      <p:grpSpPr/>
       <p:sp>
         <p:nvSpPr>
           <p:cNvPr id="2" name="Rectangle 1"/>
@@ -11868,7 +11920,6 @@
           <a:lstStyle/>
           <a:p>
             <a:pPr algn="ctr"/>
-            <a:endParaRPr/>
           </a:p>
         </p:txBody>
       </p:sp>
@@ -11939,7 +11990,7 @@
               </a:defRPr>
             </a:pPr>
             <a:r>
-              <a:t>Standard 2.0% commission. Zero fee on refunds.</a:t>
+              <a:t>4% all-in: 2.5% vendor + 1.5% buyer. Zero fee on refunds.</a:t>
             </a:r>
           </a:p>
         </p:txBody>
@@ -11984,7 +12035,6 @@
           <a:lstStyle/>
           <a:p>
             <a:pPr algn="ctr"/>
-            <a:endParaRPr/>
           </a:p>
         </p:txBody>
       </p:sp>
@@ -11997,7 +12047,7 @@
           <p:nvPr/>
         </p:nvPicPr>
         <p:blipFill>
-          <a:blip r:embed="rId3"/>
+          <a:blip r:embed="rId2"/>
           <a:stretch>
             <a:fillRect/>
           </a:stretch>
@@ -12035,14 +12085,14 @@
           <a:lstStyle/>
           <a:p>
             <a:pPr>
-              <a:defRPr sz="1200" b="1">
+              <a:defRPr b="1" sz="1200">
                 <a:solidFill>
                   <a:srgbClr val="1FC16B"/>
                 </a:solidFill>
               </a:defRPr>
             </a:pPr>
             <a:r>
-              <a:t>LEAD VERTICAL: ELECTRONICS &amp; SNEAKERS</a:t>
+              <a:t>LEAD VERTICAL: PHONES, ELECTRONICS &amp; SNEAKERS</a:t>
             </a:r>
           </a:p>
           <a:p>
@@ -12050,7 +12100,7 @@
               <a:spcBef>
                 <a:spcPts val="1000"/>
               </a:spcBef>
-              <a:defRPr sz="2200" b="1">
+              <a:defRPr b="1" sz="2200">
                 <a:solidFill>
                   <a:srgbClr val="0F172A"/>
                 </a:solidFill>
@@ -12072,7 +12122,7 @@
               </a:defRPr>
             </a:pPr>
             <a:r>
-              <a:t>Gross Commission (2.0%):  GHS 24.00</a:t>
+              <a:t>Croe Fee (4%):  GHS 48.00</a:t>
             </a:r>
           </a:p>
           <a:p>
@@ -12087,7 +12137,7 @@
               </a:defRPr>
             </a:pPr>
             <a:r>
-              <a:t>MoMo B2C Payout Fee:  - GHS 1.00</a:t>
+              <a:t>MoMo Collection (1.95%):  - GHS 23.75</a:t>
             </a:r>
           </a:p>
           <a:p>
@@ -12102,7 +12152,22 @@
               </a:defRPr>
             </a:pPr>
             <a:r>
-              <a:t>Allocated SMS / Infra:  - GHS 0.50</a:t>
+              <a:t>Payout, ID Check, SMS, Hosting:  - GHS 2.55</a:t>
+            </a:r>
+          </a:p>
+          <a:p>
+            <a:pPr>
+              <a:spcBef>
+                <a:spcPts val="1200"/>
+              </a:spcBef>
+              <a:defRPr sz="1500">
+                <a:solidFill>
+                  <a:srgbClr val="334155"/>
+                </a:solidFill>
+              </a:defRPr>
+            </a:pPr>
+            <a:r>
+              <a:t>Fraud Reserve &amp; Refunds:  - GHS 4.90</a:t>
             </a:r>
           </a:p>
           <a:p>
@@ -12117,7 +12182,7 @@
               </a:defRPr>
             </a:pPr>
             <a:r>
-              <a:t>Croe Net Margin / Txn:  ≈ GHS 22.50 – 23.00</a:t>
+              <a:t>Croe Net Margin / Order:  GHS 16.80</a:t>
             </a:r>
           </a:p>
           <a:p>
@@ -12132,7 +12197,7 @@
               </a:defRPr>
             </a:pPr>
             <a:r>
-              <a:t>Break-Even Monthly Txns:  ~22 transactions / mo</a:t>
+              <a:t>Company Break-Even:  ~37,900 orders / mo</a:t>
             </a:r>
           </a:p>
         </p:txBody>
@@ -12177,7 +12242,6 @@
           <a:lstStyle/>
           <a:p>
             <a:pPr algn="ctr"/>
-            <a:endParaRPr/>
           </a:p>
         </p:txBody>
       </p:sp>
@@ -12204,14 +12268,14 @@
           <a:lstStyle/>
           <a:p>
             <a:pPr>
-              <a:defRPr sz="1200" b="1">
+              <a:defRPr b="1" sz="1200">
                 <a:solidFill>
                   <a:srgbClr val="2563EB"/>
                 </a:solidFill>
               </a:defRPr>
             </a:pPr>
             <a:r>
-              <a:t>GENERAL SOCIAL COMMERCE BASELINE</a:t>
+              <a:t>BASE CASE: BLENDED ORDER</a:t>
             </a:r>
           </a:p>
           <a:p>
@@ -12219,14 +12283,14 @@
               <a:spcBef>
                 <a:spcPts val="1000"/>
               </a:spcBef>
-              <a:defRPr sz="2200" b="1">
+              <a:defRPr b="1" sz="2200">
                 <a:solidFill>
                   <a:srgbClr val="0F172A"/>
                 </a:solidFill>
               </a:defRPr>
             </a:pPr>
             <a:r>
-              <a:t>GHS 450 Average Order Value</a:t>
+              <a:t>GHS 800 Average Order Value</a:t>
             </a:r>
           </a:p>
           <a:p>
@@ -12241,7 +12305,7 @@
               </a:defRPr>
             </a:pPr>
             <a:r>
-              <a:t>Gross Commission (2.0%):  GHS 9.00</a:t>
+              <a:t>Croe Fee (4%):  GHS 32.00</a:t>
             </a:r>
           </a:p>
           <a:p>
@@ -12256,7 +12320,7 @@
               </a:defRPr>
             </a:pPr>
             <a:r>
-              <a:t>MoMo B2C Payout Fee:  - GHS 1.00</a:t>
+              <a:t>MoMo Collection (1.95%):  - GHS 15.83</a:t>
             </a:r>
           </a:p>
           <a:p>
@@ -12271,7 +12335,22 @@
               </a:defRPr>
             </a:pPr>
             <a:r>
-              <a:t>Allocated SMS / Infra:  - GHS 0.50</a:t>
+              <a:t>Payout, ID Check, SMS, Hosting:  - GHS 2.55</a:t>
+            </a:r>
+          </a:p>
+          <a:p>
+            <a:pPr>
+              <a:spcBef>
+                <a:spcPts val="1200"/>
+              </a:spcBef>
+              <a:defRPr sz="1500">
+                <a:solidFill>
+                  <a:srgbClr val="334155"/>
+                </a:solidFill>
+              </a:defRPr>
+            </a:pPr>
+            <a:r>
+              <a:t>Fraud Reserve &amp; Refunds:  - GHS 3.29</a:t>
             </a:r>
           </a:p>
           <a:p>
@@ -12286,7 +12365,7 @@
               </a:defRPr>
             </a:pPr>
             <a:r>
-              <a:t>Croe Net Margin / Txn:  ≈ GHS 7.50 – 8.00</a:t>
+              <a:t>Croe Net Margin / Order:  GHS 10.33</a:t>
             </a:r>
           </a:p>
           <a:p>
@@ -12301,7 +12380,7 @@
               </a:defRPr>
             </a:pPr>
             <a:r>
-              <a:t>Break-Even Monthly Txns:  ~63 transactions / mo</a:t>
+              <a:t>Company Break-Even:  ~61,700 orders / mo</a:t>
             </a:r>
           </a:p>
         </p:txBody>
@@ -12645,44 +12724,44 @@
         <a:sysClr val="window" lastClr="FFFFFF"/>
       </a:lt1>
       <a:dk2>
-        <a:srgbClr val="0E2841"/>
+        <a:srgbClr val="1F497D"/>
       </a:dk2>
       <a:lt2>
-        <a:srgbClr val="E8E8E8"/>
+        <a:srgbClr val="EEECE1"/>
       </a:lt2>
       <a:accent1>
-        <a:srgbClr val="156082"/>
+        <a:srgbClr val="4F81BD"/>
       </a:accent1>
       <a:accent2>
-        <a:srgbClr val="E97132"/>
+        <a:srgbClr val="C0504D"/>
       </a:accent2>
       <a:accent3>
-        <a:srgbClr val="196B24"/>
+        <a:srgbClr val="9BBB59"/>
       </a:accent3>
       <a:accent4>
-        <a:srgbClr val="0F9ED5"/>
+        <a:srgbClr val="8064A2"/>
       </a:accent4>
       <a:accent5>
-        <a:srgbClr val="A02B93"/>
+        <a:srgbClr val="4BACC6"/>
       </a:accent5>
       <a:accent6>
-        <a:srgbClr val="4EA72E"/>
+        <a:srgbClr val="F79646"/>
       </a:accent6>
       <a:hlink>
-        <a:srgbClr val="467886"/>
+        <a:srgbClr val="0000FF"/>
       </a:hlink>
       <a:folHlink>
-        <a:srgbClr val="96607D"/>
+        <a:srgbClr val="800080"/>
       </a:folHlink>
     </a:clrScheme>
     <a:fontScheme name="Office">
       <a:majorFont>
-        <a:latin typeface="Aptos Display" panose="02110004020202020204"/>
+        <a:latin typeface="Calibri"/>
         <a:ea typeface=""/>
         <a:cs typeface=""/>
-        <a:font script="Jpan" typeface="游ゴシック Light"/>
+        <a:font script="Jpan" typeface="ＭＳ Ｐゴシック"/>
         <a:font script="Hang" typeface="맑은 고딕"/>
-        <a:font script="Hans" typeface="等线 Light"/>
+        <a:font script="Hans" typeface="宋体"/>
         <a:font script="Hant" typeface="新細明體"/>
         <a:font script="Arab" typeface="Times New Roman"/>
         <a:font script="Hebr" typeface="Times New Roman"/>
@@ -12710,31 +12789,14 @@
         <a:font script="Viet" typeface="Times New Roman"/>
         <a:font script="Uigh" typeface="Microsoft Uighur"/>
         <a:font script="Geor" typeface="Sylfaen"/>
-        <a:font script="Armn" typeface="Arial"/>
-        <a:font script="Bugi" typeface="Leelawadee UI"/>
-        <a:font script="Bopo" typeface="Microsoft JhengHei"/>
-        <a:font script="Java" typeface="Javanese Text"/>
-        <a:font script="Lisu" typeface="Segoe UI"/>
-        <a:font script="Mymr" typeface="Myanmar Text"/>
-        <a:font script="Nkoo" typeface="Ebrima"/>
-        <a:font script="Olck" typeface="Nirmala UI"/>
-        <a:font script="Osma" typeface="Ebrima"/>
-        <a:font script="Phag" typeface="Phagspa"/>
-        <a:font script="Syrn" typeface="Estrangelo Edessa"/>
-        <a:font script="Syrj" typeface="Estrangelo Edessa"/>
-        <a:font script="Syre" typeface="Estrangelo Edessa"/>
-        <a:font script="Sora" typeface="Nirmala UI"/>
-        <a:font script="Tale" typeface="Microsoft Tai Le"/>
-        <a:font script="Talu" typeface="Microsoft New Tai Lue"/>
-        <a:font script="Tfng" typeface="Ebrima"/>
       </a:majorFont>
       <a:minorFont>
-        <a:latin typeface="Aptos" panose="02110004020202020204"/>
+        <a:latin typeface="Calibri"/>
         <a:ea typeface=""/>
         <a:cs typeface=""/>
-        <a:font script="Jpan" typeface="游ゴシック"/>
+        <a:font script="Jpan" typeface="ＭＳ Ｐゴシック"/>
         <a:font script="Hang" typeface="맑은 고딕"/>
-        <a:font script="Hans" typeface="等线"/>
+        <a:font script="Hans" typeface="宋体"/>
         <a:font script="Hant" typeface="新細明體"/>
         <a:font script="Arab" typeface="Arial"/>
         <a:font script="Hebr" typeface="Arial"/>
@@ -12762,23 +12824,6 @@
         <a:font script="Viet" typeface="Arial"/>
         <a:font script="Uigh" typeface="Microsoft Uighur"/>
         <a:font script="Geor" typeface="Sylfaen"/>
-        <a:font script="Armn" typeface="Arial"/>
-        <a:font script="Bugi" typeface="Leelawadee UI"/>
-        <a:font script="Bopo" typeface="Microsoft JhengHei"/>
-        <a:font script="Java" typeface="Javanese Text"/>
-        <a:font script="Lisu" typeface="Segoe UI"/>
-        <a:font script="Mymr" typeface="Myanmar Text"/>
-        <a:font script="Nkoo" typeface="Ebrima"/>
-        <a:font script="Olck" typeface="Nirmala UI"/>
-        <a:font script="Osma" typeface="Ebrima"/>
-        <a:font script="Phag" typeface="Phagspa"/>
-        <a:font script="Syrn" typeface="Estrangelo Edessa"/>
-        <a:font script="Syrj" typeface="Estrangelo Edessa"/>
-        <a:font script="Syre" typeface="Estrangelo Edessa"/>
-        <a:font script="Sora" typeface="Nirmala UI"/>
-        <a:font script="Tale" typeface="Microsoft Tai Le"/>
-        <a:font script="Talu" typeface="Microsoft New Tai Lue"/>
-        <a:font script="Tfng" typeface="Ebrima"/>
       </a:minorFont>
     </a:fontScheme>
     <a:fmtScheme name="Office">
@@ -12790,136 +12835,180 @@
           <a:gsLst>
             <a:gs pos="0">
               <a:schemeClr val="phClr">
-                <a:lumMod val="110000"/>
-                <a:satMod val="105000"/>
-                <a:tint val="67000"/>
+                <a:tint val="50000"/>
+                <a:satMod val="300000"/>
               </a:schemeClr>
             </a:gs>
-            <a:gs pos="50000">
+            <a:gs pos="35000">
               <a:schemeClr val="phClr">
-                <a:lumMod val="105000"/>
-                <a:satMod val="103000"/>
-                <a:tint val="73000"/>
+                <a:tint val="37000"/>
+                <a:satMod val="300000"/>
               </a:schemeClr>
             </a:gs>
             <a:gs pos="100000">
               <a:schemeClr val="phClr">
-                <a:lumMod val="105000"/>
-                <a:satMod val="109000"/>
-                <a:tint val="81000"/>
+                <a:tint val="15000"/>
+                <a:satMod val="350000"/>
               </a:schemeClr>
             </a:gs>
           </a:gsLst>
-          <a:lin ang="5400000" scaled="0"/>
+          <a:lin ang="16200000" scaled="1"/>
         </a:gradFill>
         <a:gradFill rotWithShape="1">
           <a:gsLst>
             <a:gs pos="0">
               <a:schemeClr val="phClr">
-                <a:satMod val="103000"/>
-                <a:lumMod val="102000"/>
-                <a:tint val="94000"/>
-              </a:schemeClr>
-            </a:gs>
-            <a:gs pos="50000">
-              <a:schemeClr val="phClr">
-                <a:satMod val="110000"/>
-                <a:lumMod val="100000"/>
+                <a:tint val="100000"/>
                 <a:shade val="100000"/>
+                <a:satMod val="130000"/>
               </a:schemeClr>
             </a:gs>
             <a:gs pos="100000">
               <a:schemeClr val="phClr">
-                <a:lumMod val="99000"/>
-                <a:satMod val="120000"/>
-                <a:shade val="78000"/>
+                <a:tint val="50000"/>
+                <a:shade val="100000"/>
+                <a:satMod val="350000"/>
               </a:schemeClr>
             </a:gs>
           </a:gsLst>
-          <a:lin ang="5400000" scaled="0"/>
+          <a:lin ang="16200000" scaled="0"/>
         </a:gradFill>
       </a:fillStyleLst>
       <a:lnStyleLst>
-        <a:ln w="12700" cap="flat" cmpd="sng" algn="ctr">
+        <a:ln w="9525" cap="flat" cmpd="sng" algn="ctr">
           <a:solidFill>
-            <a:schemeClr val="phClr"/>
+            <a:schemeClr val="phClr">
+              <a:shade val="95000"/>
+              <a:satMod val="105000"/>
+            </a:schemeClr>
           </a:solidFill>
           <a:prstDash val="solid"/>
-          <a:miter lim="800000"/>
-        </a:ln>
-        <a:ln w="19050" cap="flat" cmpd="sng" algn="ctr">
-          <a:solidFill>
-            <a:schemeClr val="phClr"/>
-          </a:solidFill>
-          <a:prstDash val="solid"/>
-          <a:miter lim="800000"/>
         </a:ln>
         <a:ln w="25400" cap="flat" cmpd="sng" algn="ctr">
           <a:solidFill>
             <a:schemeClr val="phClr"/>
           </a:solidFill>
           <a:prstDash val="solid"/>
-          <a:miter lim="800000"/>
+        </a:ln>
+        <a:ln w="38100" cap="flat" cmpd="sng" algn="ctr">
+          <a:solidFill>
+            <a:schemeClr val="phClr"/>
+          </a:solidFill>
+          <a:prstDash val="solid"/>
         </a:ln>
       </a:lnStyleLst>
       <a:effectStyleLst>
         <a:effectStyle>
-          <a:effectLst/>
-        </a:effectStyle>
-        <a:effectStyle>
-          <a:effectLst/>
+          <a:effectLst>
+            <a:outerShdw blurRad="40000" dist="20000" dir="5400000" rotWithShape="0">
+              <a:srgbClr val="000000">
+                <a:alpha val="38000"/>
+              </a:srgbClr>
+            </a:outerShdw>
+          </a:effectLst>
         </a:effectStyle>
         <a:effectStyle>
           <a:effectLst>
-            <a:outerShdw blurRad="57150" dist="19050" dir="5400000" algn="ctr" rotWithShape="0">
+            <a:outerShdw blurRad="40000" dist="23000" dir="5400000" rotWithShape="0">
               <a:srgbClr val="000000">
-                <a:alpha val="63000"/>
+                <a:alpha val="35000"/>
               </a:srgbClr>
             </a:outerShdw>
           </a:effectLst>
+        </a:effectStyle>
+        <a:effectStyle>
+          <a:effectLst>
+            <a:outerShdw blurRad="40000" dist="23000" dir="5400000" rotWithShape="0">
+              <a:srgbClr val="000000">
+                <a:alpha val="35000"/>
+              </a:srgbClr>
+            </a:outerShdw>
+          </a:effectLst>
+          <a:scene3d>
+            <a:camera prst="orthographicFront">
+              <a:rot lat="0" lon="0" rev="0"/>
+            </a:camera>
+            <a:lightRig rig="threePt" dir="t">
+              <a:rot lat="0" lon="0" rev="1200000"/>
+            </a:lightRig>
+          </a:scene3d>
+          <a:sp3d>
+            <a:bevelT w="63500" h="25400"/>
+          </a:sp3d>
         </a:effectStyle>
       </a:effectStyleLst>
       <a:bgFillStyleLst>
         <a:solidFill>
           <a:schemeClr val="phClr"/>
         </a:solidFill>
-        <a:solidFill>
-          <a:schemeClr val="phClr">
-            <a:tint val="95000"/>
-            <a:satMod val="170000"/>
-          </a:schemeClr>
-        </a:solidFill>
         <a:gradFill rotWithShape="1">
           <a:gsLst>
             <a:gs pos="0">
               <a:schemeClr val="phClr">
-                <a:tint val="93000"/>
-                <a:satMod val="150000"/>
-                <a:shade val="98000"/>
-                <a:lumMod val="102000"/>
+                <a:tint val="40000"/>
+                <a:satMod val="350000"/>
               </a:schemeClr>
             </a:gs>
-            <a:gs pos="50000">
+            <a:gs pos="40000">
               <a:schemeClr val="phClr">
-                <a:tint val="98000"/>
-                <a:satMod val="130000"/>
-                <a:shade val="90000"/>
-                <a:lumMod val="103000"/>
+                <a:tint val="45000"/>
+                <a:shade val="99000"/>
+                <a:satMod val="350000"/>
               </a:schemeClr>
             </a:gs>
             <a:gs pos="100000">
               <a:schemeClr val="phClr">
-                <a:shade val="63000"/>
-                <a:satMod val="120000"/>
+                <a:shade val="20000"/>
+                <a:satMod val="255000"/>
               </a:schemeClr>
             </a:gs>
           </a:gsLst>
-          <a:lin ang="5400000" scaled="0"/>
+          <a:path path="circle">
+            <a:fillToRect l="50000" t="-80000" r="50000" b="180000"/>
+          </a:path>
+        </a:gradFill>
+        <a:gradFill rotWithShape="1">
+          <a:gsLst>
+            <a:gs pos="0">
+              <a:schemeClr val="phClr">
+                <a:tint val="80000"/>
+                <a:satMod val="300000"/>
+              </a:schemeClr>
+            </a:gs>
+            <a:gs pos="100000">
+              <a:schemeClr val="phClr">
+                <a:shade val="30000"/>
+                <a:satMod val="200000"/>
+              </a:schemeClr>
+            </a:gs>
+          </a:gsLst>
+          <a:path path="circle">
+            <a:fillToRect l="50000" t="50000" r="50000" b="50000"/>
+          </a:path>
         </a:gradFill>
       </a:bgFillStyleLst>
     </a:fmtScheme>
   </a:themeElements>
   <a:objectDefaults>
+    <a:spDef>
+      <a:spPr/>
+      <a:bodyPr/>
+      <a:lstStyle/>
+      <a:style>
+        <a:lnRef idx="1">
+          <a:schemeClr val="accent1"/>
+        </a:lnRef>
+        <a:fillRef idx="3">
+          <a:schemeClr val="accent1"/>
+        </a:fillRef>
+        <a:effectRef idx="2">
+          <a:schemeClr val="accent1"/>
+        </a:effectRef>
+        <a:fontRef idx="minor">
+          <a:schemeClr val="lt1"/>
+        </a:fontRef>
+      </a:style>
+    </a:spDef>
     <a:lnDef>
       <a:spPr/>
       <a:bodyPr/>
@@ -12941,10 +13030,5 @@
     </a:lnDef>
   </a:objectDefaults>
   <a:extraClrSchemeLst/>
-  <a:extLst>
-    <a:ext uri="{05A4C25C-085E-4340-85A3-A5531E510DB2}">
-      <thm15:themeFamily xmlns:thm15="http://schemas.microsoft.com/office/thememl/2012/main" name="Office Theme" id="{2E142A2C-CD16-42D6-873A-C26D2A0506FA}" vid="{1BDDFF52-6CD6-40A5-AB3C-68EB2F1E4D0A}"/>
-    </a:ext>
-  </a:extLst>
 </a:theme>
 </file>
</xml_diff>